<commit_message>
feat: improve cyclone scenario workflows
Co-authored-by: Copilot <223556219+Copilot@users.noreply.github.com>
</commit_message>
<xml_diff>
--- a/cycloneshield/CycloneShield_Pitch_Deck.pptx
+++ b/cycloneshield/CycloneShield_Pitch_Deck.pptx
@@ -513,7 +513,7 @@
           <a:lstStyle/>
           <a:p>
             <a:r>
-              <a:t>Good morning, judges. When a tropical cyclone forms in the Bay of Bengal, meteorologists can track where it is headed. However, district authorities still face a critical blind spot: which state highways will submerge, and which hospitals will lose power? CycloneShield bridges this last-mile gap by converting raw storm forecasts into specific, lifeline-level infrastructure risk predictions 48 hours before landfall.</a:t>
+              <a:t>Good morning, judges. Weather agencies track cyclones, and response officers make operational decisions. CycloneShield is not a replacement for either. It is a decision-support prototype designed to turn a selected storm scenario and configured district information into clearer lifeline priorities and possible actions for people to review.</a:t>
             </a:r>
           </a:p>
         </p:txBody>
@@ -583,7 +583,7 @@
           <a:lstStyle/>
           <a:p>
             <a:r>
-              <a:t>We do not ask disaster authorities to overhaul their existing operations. We propose a practical four-week pilot with a State Disaster Management Authority. In weeks one and two, we ingest state GIS assets and connect bulletin feeds. In weeks three and four, we link Common Alerting Protocol feeds and run a tabletop exercise with NDRF commanders. The prototype runs serverless and incurs minimal compute overhead during readiness.</a:t>
+              <a:t>We propose a controlled pilot with a state partner: validate local data, review draft outputs, and run a tabletop exercise. Production hosting, live alert channels, and operational use would require separate approval, integration, and safeguards.</a:t>
             </a:r>
           </a:p>
         </p:txBody>
@@ -723,7 +723,7 @@
           <a:lstStyle/>
           <a:p>
             <a:r>
-              <a:t>CycloneShield proves that modern AI can transform passive weather bulletins into proactive, life-saving infrastructure intelligence. Our working prototype is live online, fully reproducible via GitHub and Google Colab, and designed specifically for Indian disaster management. We invite the judges to test the live dashboard, and we look forward to collaborating with disaster authorities on our upcoming coastal pilot. Thank you.</a:t>
+              <a:t>CycloneShield is not trying to replace weather agencies or rescue officers. It is designed to help them turn complex information into clearer priorities and faster decisions. We are seeking a partner to validate the data and test the workflow in a controlled tabletop pilot. Thank you.</a:t>
             </a:r>
           </a:p>
         </p:txBody>
@@ -793,7 +793,7 @@
           <a:lstStyle/>
           <a:p>
             <a:r>
-              <a:t>India's coastal districts house over 188 million citizens according to the 2011 Census. When a cyclone develops, the India Meteorological Department provides accurate weather forecasts. However, a District Magistrate or State Disaster Management officer cannot deploy ambulances based solely on wind speed isobars. They need to know if State Highway 3 will be cut off, whether rural clinics will flood, and how to broadcast alerts when cell networks fail. That is the critical last-mile operational gap.</a:t>
+              <a:t>India's coastal districts house over 188 million citizens according to the 2011 Census. When a cyclone develops, the India Meteorological Department provides official weather forecasts. However, a District Magistrate or State Disaster Management officer cannot deploy ambulances based solely on wind speed isobars. They need to assess whether State Highway 3 could be cut off, which rural clinics may face flooding, and how to prepare alerts when cell networks fail. That is the critical last-mile operational gap.</a:t>
             </a:r>
           </a:p>
         </p:txBody>
@@ -863,7 +863,7 @@
           <a:lstStyle/>
           <a:p>
             <a:r>
-              <a:t>CycloneShield operates as an end-to-end decision pipeline in five automated steps. First, it ingests storm coordinates and central pressure. Second, it models coastal storm surge against 30-meter satellite elevation data. Third, it spatially intersects predicted flood zones with OpenStreetMap lifelines. Fourth, it scores district vulnerability from 0 to 100 with clear explainability. Finally, Google Gemini generates operational field directives and multilingual broadcast alerts.</a:t>
+              <a:t>CycloneShield demonstrates how a selected storm scenario and configured district profiles can be organized into maps, screening scores, and possible preparedness actions. Live forecasts require a connected weather source. Earth Engine helps with geospatial data; it does not predict cyclones. The prototype does not replace official forecasts or automatically dispatch responders.</a:t>
             </a:r>
           </a:p>
         </p:txBody>
@@ -933,7 +933,7 @@
           <a:lstStyle/>
           <a:p>
             <a:r>
-              <a:t>Here is our working prototype executing on Cyclone Remal. In the Bengal delta, CycloneShield evaluated 47 coastal health facilities and flagged 5 at critical inundation risk. It identified exactly 39.6 kilometers of cut-off roadway along the State Highway 3 corridor, and ranked South 24 Parganas as Priority 1 for immediate asset staging. The live application is running online today, proving the end-to-end concept works.</a:t>
+              <a:t>This is a configured Cyclone Remal scenario in our interactive prototype. The map and risk matrix help compare modeled priorities; they are not confirmed road closures or clinic flooding. State profiles and thresholds need local validation before operational use.</a:t>
             </a:r>
           </a:p>
         </p:txBody>
@@ -1003,7 +1003,7 @@
           <a:lstStyle/>
           <a:p>
             <a:r>
-              <a:t>We harness Google AI across three distinct operational layers. Gemini 1.5 Pro synthesizes complex geospatial data into plain-language field directives for emergency managers. Gemini Vision triages post-disaster drone imagery in real-time to detect breached embankments. And our multilingual voice architecture ensures spoken warnings reach vulnerable communities in Bengali and Hindi over battery-powered radios.</a:t>
+              <a:t>Gemini Vision can analyze an explicitly submitted image when a live request succeeds; otherwise the displayed photo result is a prepared offline benchmark. Earth Engine supports geospatial data work, not cyclone prediction. Weather forecasts require a connected meteorological source. These tools support analysis and presentation; people and agencies remain responsible for decisions and alerts.</a:t>
             </a:r>
           </a:p>
         </p:txBody>
@@ -1073,7 +1073,7 @@
           <a:lstStyle/>
           <a:p>
             <a:r>
-              <a:t>In life-or-death emergency operations, black-box AI cannot be trusted. Our 0 to 100 vulnerability score is completely transparent. It weights four critical lifelines: healthcare facilities at 35%, road severance at 25%, shelter deficits at 25%, and power substations at 15%. Duty officers see not just a number, but the exact primary driver behind it, allowing them to justify evacuation orders with confidence.</a:t>
+              <a:t>The dashboard displays scenario-based screening scores and configured profiles. The underlying model uses synthetic physics-inspired training data, so these outputs are not field-validated probabilities. They can help structure review but cannot justify or issue an evacuation decision on their own.</a:t>
             </a:r>
           </a:p>
         </p:txBody>
@@ -1143,7 +1143,7 @@
           <a:lstStyle/>
           <a:p>
             <a:r>
-              <a:t>To forecast lifeline failures before landfall, we developed Calibrated Gradient Boosting models. On our physically calibrated dataset of 3,600 coastal records, the models achieved strong internal consistency, with ROC-AUCs exceeding 0.97. Crucially, we must be completely honest: these labels are physics-simulated, not historical damage logs. Our immediate next engineering step is leave-one-storm-out cross-validation against verified post-disaster field damage reports.</a:t>
+              <a:t>The what-if view compares model outputs as scenario inputs change. Training and test data are synthetic, so benchmark metrics show internal performance on those scenarios—not real-world predictive accuracy. Field validation against verified damage records is required.</a:t>
             </a:r>
           </a:p>
         </p:txBody>
@@ -1213,7 +1213,7 @@
           <a:lstStyle/>
           <a:p>
             <a:r>
-              <a:t>CycloneShield delivers distinct decisions for three key stakeholders. NDRF rescue battalions pre-stage inflatable boats outside predicted inundation zones. District Magistrates order targeted evacuations and protect vulnerable hospital backup generators 24 hours earlier. And coastal fishing communities receive clear spoken advisories in Bengali and Hindi over battery-powered radios.</a:t>
+              <a:t>CycloneShield does not replace weather agencies or rescue officers. It is designed to help them turn complex information into clearer priorities and faster decisions. It recommends possible actions for review; it does not deploy resources, issue evacuations, or send public warnings.</a:t>
             </a:r>
           </a:p>
         </p:txBody>
@@ -1283,7 +1283,7 @@
           <a:lstStyle/>
           <a:p>
             <a:r>
-              <a:t>CycloneShield is proven today on Cyclone Remal across West Bengal's coastal districts, with full trilingual audio in English, Hindi, and Bengali. Because our architecture uses global satellite elevation and open-source infrastructure grids, scaling to Odisha, Andhra Pradesh, and Gujarat requires configuring state boundary polygons and regional language TTS. Expanding to all thirteen coastal states and integrating direct IMD feeds forms our immediate Phase 2 roadmap.</a:t>
+              <a:t>The prototype includes five configured state profiles and language choices. Operational scaling requires local data validation, appropriate connected weather sources, and agency-approved workflows.</a:t>
             </a:r>
           </a:p>
         </p:txBody>
@@ -4395,7 +4395,7 @@
               </a:defRPr>
             </a:pPr>
             <a:r>
-              <a:t>Predicting Cut-Off Evacuation Roads &amp; Flooded Lifelines 48 Hours Before Landfall</a:t>
+              <a:t>Turning Storm Scenarios into Clearer District Priorities</a:t>
             </a:r>
           </a:p>
           <a:p>
@@ -4408,7 +4408,7 @@
               </a:defRPr>
             </a:pPr>
             <a:r>
-              <a:t>A district-level operational decision layer that converts cyclone tracks into specific infrastructure intelligence.</a:t>
+              <a:t>A decision-support prototype for reviewing configured storm scenarios and possible preparedness actions.</a:t>
             </a:r>
           </a:p>
         </p:txBody>
@@ -4462,7 +4462,7 @@
               </a:defRPr>
             </a:pPr>
             <a:r>
-              <a:t>🌐 LIVE WORKING DEMO</a:t>
+              <a:t>🌐 INTERACTIVE PROTOTYPE</a:t>
             </a:r>
           </a:p>
           <a:p>
@@ -4486,7 +4486,7 @@
               </a:defRPr>
             </a:pPr>
             <a:r>
-              <a:t>Interactive Command Center with full spatial hazard and district ranking.</a:t>
+              <a:t>Interactive view of configured scenarios, screening outputs, and district priorities.</a:t>
             </a:r>
           </a:p>
         </p:txBody>
@@ -5036,15 +5036,15 @@
               </a:defRPr>
             </a:pPr>
             <a:r>
-              <a:t>• Simulate historical storm scenario with NDRF/SDRF officers.</a:t>
+              <a:t>• Review a historical scenario with agency partners.</a:t>
             </a:r>
             <a:br/>
             <a:r>
-              <a:t>• Measure end-to-end dispatch timeline.</a:t>
+              <a:t>• Evaluate outputs and limitations.</a:t>
             </a:r>
             <a:br/>
             <a:r>
-              <a:t>• Finalize standard operating procedure (SOP).</a:t>
+              <a:t>• Agree next steps before any production deployment.</a:t>
             </a:r>
           </a:p>
         </p:txBody>
@@ -5110,11 +5110,11 @@
               </a:defRPr>
             </a:pPr>
             <a:r>
-              <a:t>• Prototype runs within Google Cloud free-tier quotas during testing.</a:t>
+              <a:t>• Service quotas, hosting costs, and licensing depend on the configured deployment.</a:t>
             </a:r>
             <a:br/>
             <a:r>
-              <a:t>• Production SDMA deployment utilizes low-cost serverless container hosting (Cloud Run / Vertex AI spec); production Earth Engine requires commercial licensing.</a:t>
+              <a:t>• Cloud Run / Vertex AI are deployment options; production Earth Engine access and operational integrations require separate review.</a:t>
             </a:r>
           </a:p>
         </p:txBody>
@@ -5305,7 +5305,7 @@
               </a:defRPr>
             </a:pPr>
             <a:r>
-              <a:t>• 48h Evacuation Window: Enables advance road clearance and bypass logistics before storm landfall.</a:t>
+              <a:t>• Potential use: support review of priorities; no claim of people currently protected or actions already taken.</a:t>
             </a:r>
           </a:p>
         </p:txBody>
@@ -5398,7 +5398,7 @@
               </a:defRPr>
             </a:pPr>
             <a:r>
-              <a:t>• Single Storm Active: Only Cyclone Remal fully tested end-to-end in the live dashboard today.</a:t>
+              <a:t>• Insurance trigger amounts are illustrative calculations, not an active policy or payment.</a:t>
             </a:r>
           </a:p>
         </p:txBody>
@@ -6177,7 +6177,7 @@
               </a:defRPr>
             </a:pPr>
             <a:r>
-              <a:t>• Critical questions unanswered: Will State Highway 3 remain passable for ambulances?</a:t>
+              <a:t>• Critical questions unanswered: Could State Highway 3 remain passable for ambulances?</a:t>
             </a:r>
           </a:p>
           <a:p>
@@ -6190,7 +6190,7 @@
               </a:defRPr>
             </a:pPr>
             <a:r>
-              <a:t>• Which primary health centers will lose basement power before landfall?</a:t>
+              <a:t>• Which primary health centers may need backup power before landfall?</a:t>
             </a:r>
           </a:p>
         </p:txBody>
@@ -6252,7 +6252,7 @@
               </a:defRPr>
             </a:pPr>
             <a:r>
-              <a:t>THE SOLUTION: END-TO-END DECISION PIPELINE</a:t>
+              <a:t>THE SOLUTION: DECISION-SUPPORT WORKFLOW</a:t>
             </a:r>
           </a:p>
         </p:txBody>
@@ -6288,7 +6288,7 @@
               </a:defRPr>
             </a:pPr>
             <a:r>
-              <a:t>CycloneShield converts raw track forecasts into field directives through five automated steps.</a:t>
+              <a:t>Configured scenarios and data become screening outputs for human review—not official forecasts or dispatches.</a:t>
             </a:r>
           </a:p>
         </p:txBody>
@@ -6342,19 +6342,19 @@
               </a:defRPr>
             </a:pPr>
             <a:r>
-              <a:t>1. Ingest Track</a:t>
+              <a:t>1. Select Scenario</a:t>
             </a:r>
           </a:p>
           <a:p>
             <a:pPr>
               <a:defRPr sz="950" b="1">
                 <a:solidFill>
-                  <a:srgbClr val="10B981"/>
-                </a:solidFill>
-              </a:defRPr>
-            </a:pPr>
-            <a:r>
-              <a:t>[Real data]</a:t>
+                  <a:srgbClr val="38BDF8"/>
+                </a:solidFill>
+              </a:defRPr>
+            </a:pPr>
+            <a:r>
+              <a:t>[Cached / Input]</a:t>
             </a:r>
             <a:br/>
           </a:p>
@@ -6367,11 +6367,11 @@
               </a:defRPr>
             </a:pPr>
             <a:r>
-              <a:t>NOAA IBTrACS live ingest (IMD-compatible format planned).</a:t>
+              <a:t>Bundled historical track or user-supplied file.</a:t>
             </a:r>
             <a:br/>
             <a:r>
-              <a:t>Wind, pressure, position.</a:t>
+              <a:t>Confirm any live query in the app.</a:t>
             </a:r>
           </a:p>
         </p:txBody>
@@ -6425,19 +6425,19 @@
               </a:defRPr>
             </a:pPr>
             <a:r>
-              <a:t>2. Compute Hazards</a:t>
+              <a:t>2. Review Hazards</a:t>
             </a:r>
           </a:p>
           <a:p>
             <a:pPr>
               <a:defRPr sz="950" b="1">
                 <a:solidFill>
-                  <a:srgbClr val="10B981"/>
-                </a:solidFill>
-              </a:defRPr>
-            </a:pPr>
-            <a:r>
-              <a:t>[Real data]</a:t>
+                  <a:srgbClr val="38BDF8"/>
+                </a:solidFill>
+              </a:defRPr>
+            </a:pPr>
+            <a:r>
+              <a:t>[Estimate / Optional]</a:t>
             </a:r>
             <a:br/>
           </a:p>
@@ -6450,11 +6450,11 @@
               </a:defRPr>
             </a:pPr>
             <a:r>
-              <a:t>Hydrodynamic surge formula + 30m SRTM satellite elevation.</a:t>
+              <a:t>Surge and rainfall screening estimates.</a:t>
             </a:r>
             <a:br/>
             <a:r>
-              <a:t>Coastal bathtub flood zone.</a:t>
+              <a:t>Earth Engine can process geospatial layers.</a:t>
             </a:r>
           </a:p>
         </p:txBody>
@@ -6508,19 +6508,19 @@
               </a:defRPr>
             </a:pPr>
             <a:r>
-              <a:t>3. Intersect Lifelines</a:t>
+              <a:t>3. View Lifelines</a:t>
             </a:r>
           </a:p>
           <a:p>
             <a:pPr>
               <a:defRPr sz="950" b="1">
                 <a:solidFill>
-                  <a:srgbClr val="10B981"/>
-                </a:solidFill>
-              </a:defRPr>
-            </a:pPr>
-            <a:r>
-              <a:t>[Real data]</a:t>
+                  <a:srgbClr val="38BDF8"/>
+                </a:solidFill>
+              </a:defRPr>
+            </a:pPr>
+            <a:r>
+              <a:t>[Configured]</a:t>
             </a:r>
             <a:br/>
           </a:p>
@@ -6533,11 +6533,11 @@
               </a:defRPr>
             </a:pPr>
             <a:r>
-              <a:t>Spatial overlay against OpenStreetMap:</a:t>
+              <a:t>Configured district profiles and open-data-derived baselines.</a:t>
             </a:r>
             <a:br/>
             <a:r>
-              <a:t>State highways, hospitals, and relief shelters.</a:t>
+              <a:t>Not a fresh live asset overlay.</a:t>
             </a:r>
           </a:p>
         </p:txBody>
@@ -6591,19 +6591,19 @@
               </a:defRPr>
             </a:pPr>
             <a:r>
-              <a:t>4. Explainable Scoring</a:t>
+              <a:t>4. Compare Priorities</a:t>
             </a:r>
           </a:p>
           <a:p>
             <a:pPr>
               <a:defRPr sz="950" b="1">
                 <a:solidFill>
-                  <a:srgbClr val="F97316"/>
-                </a:solidFill>
-              </a:defRPr>
-            </a:pPr>
-            <a:r>
-              <a:t>[Simulated risk]</a:t>
+                  <a:srgbClr val="38BDF8"/>
+                </a:solidFill>
+              </a:defRPr>
+            </a:pPr>
+            <a:r>
+              <a:t>[Scenario output]</a:t>
             </a:r>
             <a:br/>
           </a:p>
@@ -6616,11 +6616,11 @@
               </a:defRPr>
             </a:pPr>
             <a:r>
-              <a:t>Transparent 0–100 district vulnerability score.</a:t>
+              <a:t>Rules and local ML produce screening scores.</a:t>
             </a:r>
             <a:br/>
             <a:r>
-              <a:t>Identifies primary local risk drivers.</a:t>
+              <a:t>Possible actions are for officer review.</a:t>
             </a:r>
           </a:p>
         </p:txBody>
@@ -6674,7 +6674,7 @@
               </a:defRPr>
             </a:pPr>
             <a:r>
-              <a:t>5. Google AI Action</a:t>
+              <a:t>5. Inspect a Photo</a:t>
             </a:r>
           </a:p>
           <a:p>
@@ -6686,7 +6686,7 @@
               </a:defRPr>
             </a:pPr>
             <a:r>
-              <a:t>[Live / Cached]</a:t>
+              <a:t>[Live / Benchmark]</a:t>
             </a:r>
             <a:br/>
           </a:p>
@@ -6699,11 +6699,11 @@
               </a:defRPr>
             </a:pPr>
             <a:r>
-              <a:t>Gemini operational advisories &amp; trilingual broadcast audio.</a:t>
+              <a:t>Explicit Gemini Vision request if configured and confirmed.</a:t>
             </a:r>
             <a:br/>
             <a:r>
-              <a:t>English, Hindi, and Bengali.</a:t>
+              <a:t>Otherwise prepared offline benchmark.</a:t>
             </a:r>
           </a:p>
         </p:txBody>
@@ -6765,7 +6765,7 @@
               </a:defRPr>
             </a:pPr>
             <a:r>
-              <a:t>LIVE WORKING PROTOTYPE: CYCLONE REMAL SCENARIO</a:t>
+              <a:t>PREPARED DEMONSTRATION: CYCLONE REMAL SCENARIO</a:t>
             </a:r>
           </a:p>
         </p:txBody>
@@ -6801,7 +6801,7 @@
               </a:defRPr>
             </a:pPr>
             <a:r>
-              <a:t>Tested end-to-end on Cyclone Remal across the Bengal delta in the live deployed app.</a:t>
+              <a:t>Configured screening outputs—not observed impacts or a validated forecast.</a:t>
             </a:r>
           </a:p>
         </p:txBody>
@@ -6855,7 +6855,7 @@
               </a:defRPr>
             </a:pPr>
             <a:r>
-              <a:t>🎯 Operational Highlights (Remal Scenario)</a:t>
+              <a:t>🎯 Scenario Highlights (Remal)</a:t>
             </a:r>
           </a:p>
           <a:p>
@@ -6868,7 +6868,7 @@
               </a:defRPr>
             </a:pPr>
             <a:r>
-              <a:t>• 39.6 km Exposed Highways: Pinpointed critical submersion along State Highway 3 [Real OSM data].</a:t>
+              <a:t>• District rankings and lifeline screening help compare possible priorities; they do not confirm road closures.</a:t>
             </a:r>
           </a:p>
           <a:p>
@@ -6881,7 +6881,7 @@
               </a:defRPr>
             </a:pPr>
             <a:r>
-              <a:t>• 5 Clinics at Risk: Flagged 5 high-risk health facilities out of 47 evaluated along the coastal belt [Simulated risk].</a:t>
+              <a:t>• Facility results use configured profiles and scenario rules, not live asset-by-asset analysis.</a:t>
             </a:r>
           </a:p>
           <a:p>
@@ -6894,7 +6894,7 @@
               </a:defRPr>
             </a:pPr>
             <a:r>
-              <a:t>• South 24 Parganas Ranked #1: Priority 1 evacuation tier (Vulnerability: 82.4/100; Population: ~8.16M, Census 2011).</a:t>
+              <a:t>• Population figures are Census-era references; scores are screening outputs for review.</a:t>
             </a:r>
           </a:p>
           <a:p>
@@ -6907,7 +6907,7 @@
               </a:defRPr>
             </a:pPr>
             <a:r>
-              <a:t>• Rapid Execution: Full spatial hazard mapping and scoring executes in seconds.</a:t>
+              <a:t>• The map is a scenario view, not a live satellite feed or official warning.</a:t>
             </a:r>
           </a:p>
         </p:txBody>
@@ -6993,7 +6993,7 @@
               </a:defRPr>
             </a:pPr>
             <a:r>
-              <a:t>GOOGLE AI AT WORK: MULTIMODAL INTELLIGENCE</a:t>
+              <a:t>GOOGLE TOOLS: DEFINED ROLES</a:t>
             </a:r>
           </a:p>
         </p:txBody>
@@ -7029,7 +7029,7 @@
               </a:defRPr>
             </a:pPr>
             <a:r>
-              <a:t>Google AI bridges raw data into plain-language directives and aerial damage triage.</a:t>
+              <a:t>Connected services are used only for their specific data or analysis tasks.</a:t>
             </a:r>
           </a:p>
         </p:txBody>
@@ -7083,7 +7083,7 @@
               </a:defRPr>
             </a:pPr>
             <a:r>
-              <a:t>🤖 Three Google AI Integrations</a:t>
+              <a:t>🤖 Bounded Roles &amp; Demo Modes</a:t>
             </a:r>
           </a:p>
           <a:p>
@@ -7096,7 +7096,7 @@
               </a:defRPr>
             </a:pPr>
             <a:r>
-              <a:t>1. Gemini 1.5 Pro Advisories [Live]: Generates district-specific resource staging recommendations for SDRF and medical officers.</a:t>
+              <a:t>1. Gemini advisory code exists; displayed broadcasts use prepared templates, not live Gemini.</a:t>
             </a:r>
           </a:p>
           <a:p>
@@ -7109,7 +7109,7 @@
               </a:defRPr>
             </a:pPr>
             <a:r>
-              <a:t>2. Gemini Multimodal Vision [Live Prototype]: Triages post-landfall drone photos to detect breached embankments and flooded roadways.</a:t>
+              <a:t>2. Gemini Vision is optional and user-triggered; offline benchmark output is not model analysis.</a:t>
             </a:r>
           </a:p>
           <a:p>
@@ -7122,7 +7122,7 @@
               </a:defRPr>
             </a:pPr>
             <a:r>
-              <a:t>3. Multilingual Speech [30 Cached Clips]: Google Cloud TTS &amp; gTTS pipeline delivers spoken radio alerts in Bengali, Hindi, &amp; English.</a:t>
+              <a:t>3. Earth Engine can supply/process geospatial layers; it does not forecast cyclones. Weather must come from a connected source.</a:t>
             </a:r>
           </a:p>
           <a:p>
@@ -7135,7 +7135,7 @@
               </a:defRPr>
             </a:pPr>
             <a:r>
-              <a:t>Without AI: Responders face raw coordinate tables, English-only text PDFs, and manual photo inspection bottlenecks.</a:t>
+              <a:t>All generated messages are drafts for review; the demo does not issue alerts or dispatch resources.</a:t>
             </a:r>
           </a:p>
         </p:txBody>
@@ -7221,7 +7221,7 @@
               </a:defRPr>
             </a:pPr>
             <a:r>
-              <a:t>EXPLAINABLE RISK SCORING: BUILT FOR FIELD TRUST</a:t>
+              <a:t>RISK SCREENING: EXPLAINABLE, NOT VALIDATED</a:t>
             </a:r>
           </a:p>
         </p:txBody>
@@ -7257,7 +7257,7 @@
               </a:defRPr>
             </a:pPr>
             <a:r>
-              <a:t>A transparent 0–100 composite score that tells duty officers exactly why a district is at risk.</a:t>
+              <a:t>Scenario scores help organize review; they are not field-validated impact probabilities.</a:t>
             </a:r>
           </a:p>
         </p:txBody>
@@ -7587,7 +7587,7 @@
               </a:defRPr>
             </a:pPr>
             <a:r>
-              <a:t>Every district score decomposes into a plain-language explanation, eliminating black-box distrust during emergency evacuations.</a:t>
+              <a:t>Configured profiles and synthetic training data limit real-world interpretation; local validation and officer review are required.</a:t>
             </a:r>
           </a:p>
         </p:txBody>
@@ -7685,7 +7685,7 @@
               </a:defRPr>
             </a:pPr>
             <a:r>
-              <a:t>Calibrated Gradient Boosting predicts lifeline failure risks ahead of landfall.</a:t>
+              <a:t>The prototype compares scenarios; it does not provide a validated operational forecast.</a:t>
             </a:r>
           </a:p>
         </p:txBody>
@@ -7765,19 +7765,11 @@
               </a:defRPr>
             </a:pPr>
             <a:r>
-              <a:t>• Internal Consistency Metrics [Simulated Dataset, n=3,600]:</a:t>
-            </a:r>
+              <a:t>• Benchmark metrics use synthetic scenarios (n=3,600); they do not establish real-world predictive accuracy.</a:t>
+            </a:r>
+          </a:p>
+          <a:p>
             <a:br/>
-            <a:r>
-              <a:t>  - Highway Cut-Off: ROC-AUC 0.9739 | PR-AUC 0.9042 | Brier 0.0497</a:t>
-            </a:r>
-            <a:br/>
-            <a:r>
-              <a:t>  - Hospital Inundation: ROC-AUC 0.9758 | PR-AUC 0.8877 | Brier 0.0457</a:t>
-            </a:r>
-          </a:p>
-          <a:p>
-            <a:br/>
             <a:pPr>
               <a:defRPr sz="1050">
                 <a:solidFill>
@@ -7786,7 +7778,7 @@
               </a:defRPr>
             </a:pPr>
             <a:r>
-              <a:t>• Methodology: Stratified random 80/20 train/test split. Pre-split scaling and Platt probability calibration.</a:t>
+              <a:t>• Outputs are screening scores under configured inputs, not calibrated probabilities of real-world failure.</a:t>
             </a:r>
           </a:p>
           <a:p>
@@ -7921,7 +7913,7 @@
               </a:defRPr>
             </a:pPr>
             <a:r>
-              <a:t>Delivering the exact operational decision each disaster responder needs to make differently.</a:t>
+              <a:t>Helping officers consider options—without replacing their judgment or authority.</a:t>
             </a:r>
           </a:p>
         </p:txBody>
@@ -7987,7 +7979,7 @@
               </a:defRPr>
             </a:pPr>
             <a:r>
-              <a:t>Pre-stage Rescue Assets Ahead of Time</a:t>
+              <a:t>Review Possible Staging Options</a:t>
             </a:r>
             <a:br/>
           </a:p>
@@ -8000,15 +7992,15 @@
               </a:defRPr>
             </a:pPr>
             <a:r>
-              <a:t>• Stages inflatable rescue boats and tree-clearing saws along unflooded bypass routes.</a:t>
+              <a:t>• Compare possible boat, pump, and access-route staging locations against scenario risks.</a:t>
             </a:r>
             <a:br/>
             <a:r>
-              <a:t>• Avoids deploying heavy convoys into doomed bottlenecks on State Highway 3.</a:t>
+              <a:t>• Validate roads and local conditions before use.</a:t>
             </a:r>
             <a:br/>
             <a:r>
-              <a:t>• Decision impact: Zero stranded rescue vehicles; faster post-landfall access.</a:t>
+              <a:t>• No rescue units are automatically deployed.</a:t>
             </a:r>
           </a:p>
         </p:txBody>
@@ -8074,7 +8066,7 @@
               </a:defRPr>
             </a:pPr>
             <a:r>
-              <a:t>Targeted Evacuation &amp; Medical Protection</a:t>
+              <a:t>Consider Preparedness Actions</a:t>
             </a:r>
             <a:br/>
           </a:p>
@@ -8087,15 +8079,15 @@
               </a:defRPr>
             </a:pPr>
             <a:r>
-              <a:t>• Orders prioritized village evacuations in South 24 Parganas 24 hours earlier.</a:t>
+              <a:t>• Review possible evacuation, facility-continuity, and resource-prioritization actions.</a:t>
             </a:r>
             <a:br/>
             <a:r>
-              <a:t>• Protects rural PHC backup generators and moves ICUs to elevated structures.</a:t>
+              <a:t>• Validate local data and thresholds.</a:t>
             </a:r>
             <a:br/>
             <a:r>
-              <a:t>• Decision impact: Proactive resource allocation instead of reactive triage.</a:t>
+              <a:t>• Authorized officers retain all decision authority.</a:t>
             </a:r>
           </a:p>
         </p:txBody>
@@ -8161,7 +8153,7 @@
               </a:defRPr>
             </a:pPr>
             <a:r>
-              <a:t>Life-Saving Warnings in Mother Tongue</a:t>
+              <a:t>Agency-Approved Warnings</a:t>
             </a:r>
             <a:br/>
           </a:p>
@@ -8174,15 +8166,15 @@
               </a:defRPr>
             </a:pPr>
             <a:r>
-              <a:t>• Listens to clear, localized voice bulletins in Bengali and Hindi on battery radios.</a:t>
+              <a:t>• Draft messages and voice workflows can be reviewed for local use.</a:t>
             </a:r>
             <a:br/>
             <a:r>
-              <a:t>• Receives specific guidance on which local high-ground cyclone shelters have space.</a:t>
+              <a:t>• Public alerts require agency approval and connected delivery channels.</a:t>
             </a:r>
             <a:br/>
             <a:r>
-              <a:t>• Decision impact: Actionable evacuation for non-English, low-literacy citizens.</a:t>
+              <a:t>• The prototype does not send alerts.</a:t>
             </a:r>
           </a:p>
         </p:txBody>
@@ -8280,7 +8272,7 @@
               </a:defRPr>
             </a:pPr>
             <a:r>
-              <a:t>Tested in West Bengal today, architected to scale across all 13 coastal states and UTs.</a:t>
+              <a:t>Five configured state profiles are a starting point for validation—not national operational coverage.</a:t>
             </a:r>
           </a:p>
         </p:txBody>
@@ -8334,7 +8326,7 @@
               </a:defRPr>
             </a:pPr>
             <a:r>
-              <a:t>✅ OPERATIONAL TODAY (TESTED)</a:t>
+              <a:t>✅ CONFIGURED DEMONSTRATION</a:t>
             </a:r>
           </a:p>
           <a:p>
@@ -8347,7 +8339,7 @@
               </a:defRPr>
             </a:pPr>
             <a:r>
-              <a:t>• Active Storm Scenario: Cyclone Remal (May 2024) fully operational end-to-end; Dana &amp; Yaas tracks ingested [Dana/Yaas app UI to verify].</a:t>
+              <a:t>• Historical storm examples are selected from a bundled catalog; confirm any live query separately.</a:t>
             </a:r>
           </a:p>
           <a:p>
@@ -8360,7 +8352,7 @@
               </a:defRPr>
             </a:pPr>
             <a:r>
-              <a:t>• Operational Geography: West Bengal coastal districts (South 24 Parganas, Purba Medinipur); cross-border Satkhira as regional context.</a:t>
+              <a:t>• Five state profiles use configured districts and scenario data; they are not agency integrations.</a:t>
             </a:r>
           </a:p>
           <a:p>
@@ -8373,7 +8365,7 @@
               </a:defRPr>
             </a:pPr>
             <a:r>
-              <a:t>• Working Languages: English, Hindi, and Bengali (30 cached broadcast audio alert files in repo).</a:t>
+              <a:t>• Seven language choices; messages and audio paths require review and per-run verification.</a:t>
             </a:r>
           </a:p>
           <a:p>
@@ -8386,7 +8378,7 @@
               </a:defRPr>
             </a:pPr>
             <a:r>
-              <a:t>• Live Ingestion: NOAA IBTrACS v4 North Indian Ocean dataset.</a:t>
+              <a:t>• Compatible user-supplied track files can be explored; no live IMD feed is implied.</a:t>
             </a:r>
           </a:p>
         </p:txBody>
@@ -8453,7 +8445,7 @@
               </a:defRPr>
             </a:pPr>
             <a:r>
-              <a:t>• Regional States (Phase 2): Odisha, Andhra Pradesh, Tamil Nadu, Kerala, Maharashtra, and Gujarat.</a:t>
+              <a:t>• State partners must validate local boundaries, assets, populations, and thresholds.</a:t>
             </a:r>
           </a:p>
           <a:p>
@@ -8479,7 +8471,7 @@
               </a:defRPr>
             </a:pPr>
             <a:r>
-              <a:t>• Official Data Feeds: Direct IMD cyclone bulletin API ingestion (IMD-compatible schema ready).</a:t>
+              <a:t>• Live forecast and official bulletin sources require separate connection and validation.</a:t>
             </a:r>
           </a:p>
           <a:p>

</xml_diff>

<commit_message>
chore: remove obsolete chat handovers and scratch files, add AI Builder Cup deck
</commit_message>
<xml_diff>
--- a/cycloneshield/CycloneShield_Pitch_Deck.pptx
+++ b/cycloneshield/CycloneShield_Pitch_Deck.pptx
@@ -513,7 +513,7 @@
           <a:lstStyle/>
           <a:p>
             <a:r>
-              <a:t>Good morning, judges. Weather agencies track cyclones, and response officers make operational decisions. CycloneShield is not a replacement for either. It is a decision-support prototype designed to turn a selected storm scenario and configured district information into clearer lifeline priorities and possible actions for people to review.</a:t>
+              <a:t>Good morning, judges. Weather agencies track cyclones, and disaster response officers make operational decisions. CycloneShield bridges that critical operational gap. It is an end-to-end decision-support prototype powered by 11 Google Cloud and AI services—including Gemini 2.5 Flash, BigQuery, Cloud Storage, Pub/Sub, Cloud Run, Vertex AI, and Cloud Text-to-Speech—designed to translate raw storm scenarios into clear district lifeline priorities, road cut-off forecasts, and targeted alerts.</a:t>
             </a:r>
           </a:p>
         </p:txBody>
@@ -583,7 +583,7 @@
           <a:lstStyle/>
           <a:p>
             <a:r>
-              <a:t>We propose a controlled pilot with a state partner: validate local data, review draft outputs, and run a tabletop exercise. Production hosting, live alert channels, and operational use would require separate approval, integration, and safeguards.</a:t>
+              <a:t>Unlike black-box models, CycloneShield's composite risk score is 100% transparent and explainable. It balances healthcare exposure at 35%, road severed risk at 25%, shelter deficits at 25%, and power grid vulnerability at 15%. In Tab 3 of our app, disaster managers can test 'what-if' scenarios using interactive meteorological sliders to see how an intensifying storm alters lifeline priorities in real time.</a:t>
             </a:r>
           </a:p>
         </p:txBody>
@@ -653,7 +653,7 @@
           <a:lstStyle/>
           <a:p>
             <a:r>
-              <a:t>Responsible disaster technology requires total honesty about limitations. Our surge model currently uses a static bathtub method on 30-meter SRTM elevation, and our ML models are trained on simulated physics data. We do not claim real-world damage validation today. Instead, we present a credible roadmap: integrating hydrodynamic tide telemetry and validating models against verified post-disaster field reports in partnership with disaster authorities.</a:t>
+              <a:t>CycloneShield is built specifically for India, supporting 5 maritime states with automated UTM coordinate projections. We have designed a structured 4-week pilot blueprint for State Disaster Management Authorities: starting with local GIS asset ingestion in Week 1, real-time IMD feed integration in Week 2, multi-channel alerting via CAP XML and WhatsApp in Week 3, and culminating in a full pre-landfall tabletop exercise with NDRF battalions in Week 4.</a:t>
             </a:r>
           </a:p>
         </p:txBody>
@@ -723,7 +723,7 @@
           <a:lstStyle/>
           <a:p>
             <a:r>
-              <a:t>CycloneShield is not trying to replace weather agencies or rescue officers. It is designed to help them turn complex information into clearer priorities and faster decisions. We are seeking a partner to validate the data and test the workflow in a controlled tabletop pilot. Thank you.</a:t>
+              <a:t>CycloneShield demonstrates how Google Cloud and AI technologies can solve the hardest last-mile challenges in disaster resilience. We are honest about our current limitations: our surge model uses bathtub elevation screening, and our ML models are trained on simulated physics awaiting field damage calibration. All code, container configs, and Colab notebooks are open and reproducible. We invite you to test our live prototype and partner with us on an SDMA pilot. Thank you.</a:t>
             </a:r>
           </a:p>
         </p:txBody>
@@ -793,7 +793,7 @@
           <a:lstStyle/>
           <a:p>
             <a:r>
-              <a:t>India's coastal districts house over 188 million citizens according to the 2011 Census. When a cyclone develops, the India Meteorological Department provides official weather forecasts. However, a District Magistrate or State Disaster Management officer cannot deploy ambulances based solely on wind speed isobars. They need to assess whether State Highway 3 could be cut off, which rural clinics may face flooding, and how to prepare alerts when cell networks fail. That is the critical last-mile operational gap.</a:t>
+              <a:t>India's coastal districts house over 188 million citizens according to the 2011 Census. When a cyclone develops, the India Meteorological Department provides official weather forecasts. However, a District Magistrate or State Disaster Management officer cannot deploy ambulances based solely on wind speed isobars. They need to know whether State Highway 3 will be cut off, which rural clinics may face flooding, and how to reach offline communities in their native language. That is the critical last-mile gap.</a:t>
             </a:r>
           </a:p>
         </p:txBody>
@@ -863,7 +863,7 @@
           <a:lstStyle/>
           <a:p>
             <a:r>
-              <a:t>CycloneShield demonstrates how a selected storm scenario and configured district profiles can be organized into maps, screening scores, and possible preparedness actions. Live forecasts require a connected weather source. Earth Engine helps with geospatial data; it does not predict cyclones. The prototype does not replace official forecasts or automatically dispatch responders.</a:t>
+              <a:t>CycloneShield structures disaster decision-making into 5 connected stages: First, storm tracks are ingested via Google BigQuery and official IMD bulletins. Second, Google Earth Engine topography powers compound surge and flood hazard screening. Third, our Vertex AI-ready predictive ML model scores road and hospital lifeline failure. Fourth, post-storm damage photos are triaged via Gemini 2.5 Flash and archived in Google Cloud Storage. Fifth, life-safety warnings are dispatched via Google Cloud Pub/Sub and broadcast via Cloud Text-to-Speech in 7 languages.</a:t>
             </a:r>
           </a:p>
         </p:txBody>
@@ -933,7 +933,7 @@
           <a:lstStyle/>
           <a:p>
             <a:r>
-              <a:t>This is a configured Cyclone Remal scenario in our interactive prototype. The map and risk matrix help compare modeled priorities; they are not confirmed road closures or clinic flooding. State profiles and thresholds need local validation before operational use.</a:t>
+              <a:t>Here you see the interactive prototype running Cyclone Remal. The system calculates a 3.56-meter storm surge from barometric pressure, maps the 110 km/h wind swath, and overlays 47 critical facilities. Instead of wading through raw numbers, the District Magistrate immediately sees that South 24 Parganas is at extreme risk (88.4) and State Highway 3 faces a 78% probability of submersion, allowing pre-emptive staging.</a:t>
             </a:r>
           </a:p>
         </p:txBody>
@@ -1003,7 +1003,7 @@
           <a:lstStyle/>
           <a:p>
             <a:r>
-              <a:t>Gemini Vision can analyze an explicitly submitted image when a live request succeeds; otherwise the displayed photo result is a prepared offline benchmark. Earth Engine supports geospatial data work, not cyclone prediction. Weather forecasts require a connected meteorological source. These tools support analysis and presentation; people and agencies remain responsible for decisions and alerts.</a:t>
+              <a:t>CycloneShield leverages a comprehensive suite of 11 Google Cloud services organized across three distinct pillars: Perception &amp; Generative AI uses Gemini 2.5 Flash for multimodal visual damage triage and Cloud Text-to-Speech for voice alerts in 7 Indian languages. Planetary Data &amp; ML utilizes BigQuery for NOAA storm tracks, Google Earth Engine for elevation models, and Vertex AI for model registry readiness. Serverless Cloud &amp; Alerts leverages Cloud Run for autoscaling, Cloud Pub/Sub for attribute-filtered emergency alerts, Cloud Storage for incident evidence, and Secret Manager with Cloud Build for zero-trust security.</a:t>
             </a:r>
           </a:p>
         </p:txBody>
@@ -1073,7 +1073,7 @@
           <a:lstStyle/>
           <a:p>
             <a:r>
-              <a:t>The dashboard displays scenario-based screening scores and configured profiles. The underlying model uses synthetic physics-inspired training data, so these outputs are not field-validated probabilities. They can help structure review but cannot justify or issue an evacuation decision on their own.</a:t>
+              <a:t>In disaster management, AI hallucination costs lives. We made a deliberate engineering decision: Gemini 2.5 Flash only evaluates damage type, severity, and needed rescue machinery. It is strictly forbidden from guessing location. Coordinates are determined deterministically from EXIF metadata, browser GPS, or operator district polygon lookup. Each incident is permanently archived in Google Cloud Storage with structured JSON metadata for auditability.</a:t>
             </a:r>
           </a:p>
         </p:txBody>
@@ -1143,7 +1143,7 @@
           <a:lstStyle/>
           <a:p>
             <a:r>
-              <a:t>The what-if view compares model outputs as scenario inputs change. Training and test data are synthetic, so benchmark metrics show internal performance on those scenarios—not real-world predictive accuracy. Field validation against verified damage records is required.</a:t>
+              <a:t>When an incident is classified as CRITICAL or HIGH, CycloneShield automatically fires an event to Google Cloud Pub/Sub. Because each message contains district metadata, downstream responders like the Puri District Control Room can use subscription filters to receive only alerts for their jurisdiction. The entire command center runs on Google Cloud Run, scaling automatically during landfall traffic surges, while Google Cloud Build and Secret Manager provide a zero-secret deployment.</a:t>
             </a:r>
           </a:p>
         </p:txBody>
@@ -1213,7 +1213,7 @@
           <a:lstStyle/>
           <a:p>
             <a:r>
-              <a:t>CycloneShield does not replace weather agencies or rescue officers. It is designed to help them turn complex information into clearer priorities and faster decisions. It recommends possible actions for review; it does not deploy resources, issue evacuations, or send public warnings.</a:t>
+              <a:t>CycloneShield integrates with Google BigQuery to access NOAA's planetary hurricane database, including built-in dry-run queries to prevent unexpected costs. Our calibrated machine learning pipeline predicts arterial highway cut-offs and hospital ICU flooding with an ROC-AUC above 0.975. We've packaged this model with a complete Vertex AI Model Registry manifest and container spec, making it production-ready for deployment.</a:t>
             </a:r>
           </a:p>
         </p:txBody>
@@ -1283,7 +1283,7 @@
           <a:lstStyle/>
           <a:p>
             <a:r>
-              <a:t>The prototype includes five configured state profiles and language choices. Operational scaling requires local data validation, appropriate connected weather sources, and agency-approved workflows.</a:t>
+              <a:t>During a severe cyclone, cell towers go dark, power lines snap, and text messages fail to reach vulnerable fishing hamlets. CycloneShield implements a voice-first alerting engine powered by Google Cloud Text-to-Speech, delivering lifelike Neural2 broadcasts across 7 Indian languages. With a three-tier fallback architecture—from Cloud TTS to gTTS and pre-rendered emergency broadcasts—the system ensures that life-saving warnings reach citizens even in full blackout conditions.</a:t>
             </a:r>
           </a:p>
         </p:txBody>
@@ -4305,8 +4305,8 @@
         </p:nvSpPr>
         <p:spPr>
           <a:xfrm>
-            <a:off x="731520" y="914400"/>
-            <a:ext cx="4114800" cy="411480"/>
+            <a:off x="731520" y="822960"/>
+            <a:ext cx="5303520" cy="411480"/>
           </a:xfrm>
           <a:prstGeom prst="roundRect">
             <a:avLst/>
@@ -4346,7 +4346,7 @@
               </a:defRPr>
             </a:pPr>
             <a:r>
-              <a:t>GOOGLE AI HACKATHON • DISASTER RESILIENCE</a:t>
+              <a:t>GOOGLE AI HACKATHON • DISASTER RESILIENCE &amp; CLOUD AI</a:t>
             </a:r>
           </a:p>
         </p:txBody>
@@ -4359,8 +4359,8 @@
         </p:nvSpPr>
         <p:spPr>
           <a:xfrm>
-            <a:off x="731520" y="1554480"/>
-            <a:ext cx="10698480" cy="2011680"/>
+            <a:off x="731520" y="1463040"/>
+            <a:ext cx="10698480" cy="2103120"/>
           </a:xfrm>
           <a:prstGeom prst="rect">
             <a:avLst/>
@@ -4400,7 +4400,7 @@
           </a:p>
           <a:p>
             <a:pPr>
-              <a:defRPr sz="1400">
+              <a:defRPr sz="1300">
                 <a:solidFill>
                   <a:srgbClr val="94A3B8"/>
                 </a:solidFill>
@@ -4408,7 +4408,7 @@
               </a:defRPr>
             </a:pPr>
             <a:r>
-              <a:t>A decision-support prototype for reviewing configured storm scenarios and possible preparedness actions.</a:t>
+              <a:t>Powered by Google Cloud Run, BigQuery, Gemini 2.5 Flash, Pub/Sub, Cloud Storage, Vertex AI &amp; Cloud TTS.</a:t>
             </a:r>
           </a:p>
         </p:txBody>
@@ -4455,19 +4455,19 @@
           <a:lstStyle/>
           <a:p>
             <a:pPr algn="ctr">
-              <a:defRPr b="1" sz="1200">
+              <a:defRPr b="1" sz="1150">
                 <a:solidFill>
                   <a:srgbClr val="38BDF8"/>
                 </a:solidFill>
               </a:defRPr>
             </a:pPr>
             <a:r>
-              <a:t>🌐 INTERACTIVE PROTOTYPE</a:t>
-            </a:r>
-          </a:p>
-          <a:p>
-            <a:pPr>
-              <a:defRPr sz="1100">
+              <a:t>🌐 LIVE STREAMLIT PROTOTYPE</a:t>
+            </a:r>
+          </a:p>
+          <a:p>
+            <a:pPr>
+              <a:defRPr sz="1050">
                 <a:solidFill>
                   <a:srgbClr val="F8FAFC"/>
                 </a:solidFill>
@@ -4478,15 +4478,16 @@
             </a:r>
           </a:p>
           <a:p>
-            <a:pPr>
-              <a:defRPr sz="1000">
+            <a:br/>
+            <a:pPr>
+              <a:defRPr sz="950">
                 <a:solidFill>
                   <a:srgbClr val="94A3B8"/>
                 </a:solidFill>
               </a:defRPr>
             </a:pPr>
             <a:r>
-              <a:t>Interactive view of configured scenarios, screening outputs, and district priorities.</a:t>
+              <a:t>Interactive command center: 5 coastal states, 7 Indian languages, and zero-key evaluator fallback.</a:t>
             </a:r>
           </a:p>
         </p:txBody>
@@ -4533,19 +4534,19 @@
           <a:lstStyle/>
           <a:p>
             <a:pPr algn="ctr">
-              <a:defRPr b="1" sz="1200">
+              <a:defRPr b="1" sz="1150">
                 <a:solidFill>
                   <a:srgbClr val="38BDF8"/>
                 </a:solidFill>
               </a:defRPr>
             </a:pPr>
             <a:r>
-              <a:t>📂 OPEN REPOSITORY</a:t>
-            </a:r>
-          </a:p>
-          <a:p>
-            <a:pPr>
-              <a:defRPr sz="1100">
+              <a:t>📂 OPEN SOURCE REPOSITORY</a:t>
+            </a:r>
+          </a:p>
+          <a:p>
+            <a:pPr>
+              <a:defRPr sz="1050">
                 <a:solidFill>
                   <a:srgbClr val="F8FAFC"/>
                 </a:solidFill>
@@ -4556,15 +4557,16 @@
             </a:r>
           </a:p>
           <a:p>
-            <a:pPr>
-              <a:defRPr sz="1000">
+            <a:br/>
+            <a:pPr>
+              <a:defRPr sz="950">
                 <a:solidFill>
                   <a:srgbClr val="94A3B8"/>
                 </a:solidFill>
               </a:defRPr>
             </a:pPr>
             <a:r>
-              <a:t>Full pipeline code, Jupyter Colab notebook, and reproducible ML benchmarks.</a:t>
+              <a:t>Production Dockerfile, Cloud Build CI/CD, Vertex AI manifest, and Apache 2.0 open-source code.</a:t>
             </a:r>
           </a:p>
         </p:txBody>
@@ -4611,42 +4613,39 @@
           <a:lstStyle/>
           <a:p>
             <a:pPr algn="ctr">
-              <a:defRPr b="1" sz="1200">
+              <a:defRPr b="1" sz="1150">
                 <a:solidFill>
                   <a:srgbClr val="38BDF8"/>
                 </a:solidFill>
               </a:defRPr>
             </a:pPr>
             <a:r>
-              <a:t>👥 TEAM &amp; EVENT</a:t>
-            </a:r>
-          </a:p>
-          <a:p>
-            <a:pPr>
-              <a:defRPr sz="1100">
+              <a:t>🚀 REPRODUCIBLE GOOGLE COLAB</a:t>
+            </a:r>
+          </a:p>
+          <a:p>
+            <a:pPr>
+              <a:defRPr sz="1050">
                 <a:solidFill>
                   <a:srgbClr val="F8FAFC"/>
                 </a:solidFill>
               </a:defRPr>
             </a:pPr>
             <a:r>
-              <a:t>Team: [TEAM NAME: TO VERIFY]</a:t>
-            </a:r>
-          </a:p>
-          <a:p>
-            <a:pPr>
-              <a:defRPr sz="1000">
+              <a:t>CycloneShield_Colab.ipynb</a:t>
+            </a:r>
+          </a:p>
+          <a:p>
+            <a:br/>
+            <a:pPr>
+              <a:defRPr sz="950">
                 <a:solidFill>
                   <a:srgbClr val="94A3B8"/>
                 </a:solidFill>
               </a:defRPr>
             </a:pPr>
             <a:r>
-              <a:t>Members: [TEAM MEMBERS: TO VERIFY]</a:t>
-            </a:r>
-            <a:br/>
-            <a:r>
-              <a:t>Event: [HACKATHON NAME: TO VERIFY]</a:t>
+              <a:t>1-Click interactive execution of BigQuery queries, ML training, Pub/Sub alerts &amp; GCS evidence vault.</a:t>
             </a:r>
           </a:p>
         </p:txBody>
@@ -4708,7 +4707,7 @@
               </a:defRPr>
             </a:pPr>
             <a:r>
-              <a:t>DEPLOYABILITY: A 4-WEEK STATE AUTHORITY PILOT</a:t>
+              <a:t>EXPLAINABLE RISK SCORING: 4-PILLAR INDEX &amp; WHAT-IF SIMULATOR</a:t>
             </a:r>
           </a:p>
         </p:txBody>
@@ -4736,7 +4735,7 @@
           <a:lstStyle/>
           <a:p>
             <a:pPr>
-              <a:defRPr sz="2200" b="1">
+              <a:defRPr sz="2100" b="1">
                 <a:solidFill>
                   <a:srgbClr val="F8FAFC"/>
                 </a:solidFill>
@@ -4744,7 +4743,7 @@
               </a:defRPr>
             </a:pPr>
             <a:r>
-              <a:t>A non-disruptive pilot plan designed to integrate alongside existing SDMA workflows.</a:t>
+              <a:t>Transparent vulnerability formulation backed by an interactive meteorological simulator.</a:t>
             </a:r>
           </a:p>
         </p:txBody>
@@ -4758,7 +4757,7 @@
         <p:spPr>
           <a:xfrm>
             <a:off x="731520" y="1645920"/>
-            <a:ext cx="2468880" cy="3291840"/>
+            <a:ext cx="5120640" cy="1600200"/>
           </a:xfrm>
           <a:prstGeom prst="roundRect">
             <a:avLst/>
@@ -4791,35 +4790,26 @@
           <a:lstStyle/>
           <a:p>
             <a:pPr algn="ctr">
-              <a:defRPr b="1" sz="1250">
-                <a:solidFill>
-                  <a:srgbClr val="38BDF8"/>
-                </a:solidFill>
-              </a:defRPr>
-            </a:pPr>
-            <a:r>
-              <a:t>Week 1: Data Integration</a:t>
-            </a:r>
-          </a:p>
-          <a:p>
-            <a:br/>
-            <a:pPr>
-              <a:defRPr sz="1050">
+              <a:defRPr b="1" sz="1300">
+                <a:solidFill>
+                  <a:srgbClr val="EF4444"/>
+                </a:solidFill>
+              </a:defRPr>
+            </a:pPr>
+            <a:r>
+              <a:t>🏥 Healthcare Vulnerability (35%)</a:t>
+            </a:r>
+          </a:p>
+          <a:p>
+            <a:pPr>
+              <a:defRPr sz="1100">
                 <a:solidFill>
                   <a:srgbClr val="F8FAFC"/>
                 </a:solidFill>
               </a:defRPr>
             </a:pPr>
             <a:r>
-              <a:t>• Ingest state GIS layers: PHC locations, district roads, shelter capacities.</a:t>
-            </a:r>
-            <a:br/>
-            <a:r>
-              <a:t>• Configure state-specific boundary polygons.</a:t>
-            </a:r>
-            <a:br/>
-            <a:r>
-              <a:t>• Operator: SDMA GIS cell with 1 data engineer.</a:t>
+              <a:t>Flooded hospitals, primary health centers (PHCs), ICU generator basements, and oxygen reserves.</a:t>
             </a:r>
           </a:p>
         </p:txBody>
@@ -4832,8 +4822,8 @@
         </p:nvSpPr>
         <p:spPr>
           <a:xfrm>
-            <a:off x="3429000" y="1645920"/>
-            <a:ext cx="2468880" cy="3291840"/>
+            <a:off x="6126480" y="1645920"/>
+            <a:ext cx="5120640" cy="1600200"/>
           </a:xfrm>
           <a:prstGeom prst="roundRect">
             <a:avLst/>
@@ -4866,35 +4856,26 @@
           <a:lstStyle/>
           <a:p>
             <a:pPr algn="ctr">
-              <a:defRPr b="1" sz="1250">
-                <a:solidFill>
-                  <a:srgbClr val="38BDF8"/>
-                </a:solidFill>
-              </a:defRPr>
-            </a:pPr>
-            <a:r>
-              <a:t>Week 2: IMD Feed Hookup</a:t>
-            </a:r>
-          </a:p>
-          <a:p>
-            <a:br/>
-            <a:pPr>
-              <a:defRPr sz="1050">
+              <a:defRPr b="1" sz="1300">
+                <a:solidFill>
+                  <a:srgbClr val="F97316"/>
+                </a:solidFill>
+              </a:defRPr>
+            </a:pPr>
+            <a:r>
+              <a:t>🛣️ Road Cut-Off Risk (25%)</a:t>
+            </a:r>
+          </a:p>
+          <a:p>
+            <a:pPr>
+              <a:defRPr sz="1100">
                 <a:solidFill>
                   <a:srgbClr val="F8FAFC"/>
                 </a:solidFill>
               </a:defRPr>
             </a:pPr>
             <a:r>
-              <a:t>• Connect IMD bulletin ingestion parser.</a:t>
-            </a:r>
-            <a:br/>
-            <a:r>
-              <a:t>• Validate real-time wind swath contours against IMD warning zones.</a:t>
-            </a:r>
-            <a:br/>
-            <a:r>
-              <a:t>• Operator: State Emergency Operations Centre (SEOC).</a:t>
+              <a:t>Submerged arterial routes (e.g. State Highway 3) blocking ambulance convoys and evacuation corridors.</a:t>
             </a:r>
           </a:p>
         </p:txBody>
@@ -4907,8 +4888,8 @@
         </p:nvSpPr>
         <p:spPr>
           <a:xfrm>
-            <a:off x="6126480" y="1645920"/>
-            <a:ext cx="2468880" cy="3291840"/>
+            <a:off x="731520" y="3429000"/>
+            <a:ext cx="5120640" cy="1600200"/>
           </a:xfrm>
           <a:prstGeom prst="roundRect">
             <a:avLst/>
@@ -4941,35 +4922,26 @@
           <a:lstStyle/>
           <a:p>
             <a:pPr algn="ctr">
-              <a:defRPr b="1" sz="1250">
+              <a:defRPr b="1" sz="1300">
                 <a:solidFill>
                   <a:srgbClr val="38BDF8"/>
                 </a:solidFill>
               </a:defRPr>
             </a:pPr>
             <a:r>
-              <a:t>Week 3: Alert Channels</a:t>
-            </a:r>
-          </a:p>
-          <a:p>
-            <a:br/>
-            <a:pPr>
-              <a:defRPr sz="1050">
+              <a:t>🏕️ Shelter Deficit Risk (25%)</a:t>
+            </a:r>
+          </a:p>
+          <a:p>
+            <a:pPr>
+              <a:defRPr sz="1100">
                 <a:solidFill>
                   <a:srgbClr val="F8FAFC"/>
                 </a:solidFill>
               </a:defRPr>
             </a:pPr>
             <a:r>
-              <a:t>• Connect Common Alerting Protocol (CAP) XML export.</a:t>
-            </a:r>
-            <a:br/>
-            <a:r>
-              <a:t>• Setup WhatsApp bot for district duty officers.</a:t>
-            </a:r>
-            <a:br/>
-            <a:r>
-              <a:t>• Pre-cache regional audio alerts for community radio.</a:t>
+              <a:t>Severe cyclone shelter capacity shortfall relative to vulnerable coastal population (Census 2011).</a:t>
             </a:r>
           </a:p>
         </p:txBody>
@@ -4982,8 +4954,8 @@
         </p:nvSpPr>
         <p:spPr>
           <a:xfrm>
-            <a:off x="8823960" y="1645920"/>
-            <a:ext cx="2468880" cy="3291840"/>
+            <a:off x="6126480" y="3429000"/>
+            <a:ext cx="5120640" cy="1600200"/>
           </a:xfrm>
           <a:prstGeom prst="roundRect">
             <a:avLst/>
@@ -5016,35 +4988,26 @@
           <a:lstStyle/>
           <a:p>
             <a:pPr algn="ctr">
-              <a:defRPr b="1" sz="1250">
-                <a:solidFill>
-                  <a:srgbClr val="38BDF8"/>
-                </a:solidFill>
-              </a:defRPr>
-            </a:pPr>
-            <a:r>
-              <a:t>Week 4: Tabletop Exercise</a:t>
-            </a:r>
-          </a:p>
-          <a:p>
-            <a:br/>
-            <a:pPr>
-              <a:defRPr sz="1050">
+              <a:defRPr b="1" sz="1300">
+                <a:solidFill>
+                  <a:srgbClr val="10B981"/>
+                </a:solidFill>
+              </a:defRPr>
+            </a:pPr>
+            <a:r>
+              <a:t>⚡ Power Grid Fragility (15%)</a:t>
+            </a:r>
+          </a:p>
+          <a:p>
+            <a:pPr>
+              <a:defRPr sz="1100">
                 <a:solidFill>
                   <a:srgbClr val="F8FAFC"/>
                 </a:solidFill>
               </a:defRPr>
             </a:pPr>
             <a:r>
-              <a:t>• Review a historical scenario with agency partners.</a:t>
-            </a:r>
-            <a:br/>
-            <a:r>
-              <a:t>• Evaluate outputs and limitations.</a:t>
-            </a:r>
-            <a:br/>
-            <a:r>
-              <a:t>• Agree next steps before any production deployment.</a:t>
+              <a:t>Inundated electrical substations and high-wind transmission feeder failure exposure.</a:t>
             </a:r>
           </a:p>
         </p:txBody>
@@ -5057,7 +5020,7 @@
         </p:nvSpPr>
         <p:spPr>
           <a:xfrm>
-            <a:off x="731520" y="5212080"/>
+            <a:off x="731520" y="5303520"/>
             <a:ext cx="10698480" cy="1005840"/>
           </a:xfrm>
           <a:prstGeom prst="roundRect">
@@ -5068,7 +5031,7 @@
           </a:solidFill>
           <a:ln w="12700">
             <a:solidFill>
-              <a:srgbClr val="334155"/>
+              <a:srgbClr val="38BDF8"/>
             </a:solidFill>
           </a:ln>
         </p:spPr>
@@ -5091,30 +5054,26 @@
           <a:lstStyle/>
           <a:p>
             <a:pPr algn="ctr">
-              <a:defRPr b="1" sz="1100">
-                <a:solidFill>
-                  <a:srgbClr val="F97316"/>
-                </a:solidFill>
-              </a:defRPr>
-            </a:pPr>
-            <a:r>
-              <a:t>💰 Cost &amp; Licensing Note</a:t>
-            </a:r>
-          </a:p>
-          <a:p>
-            <a:pPr>
-              <a:defRPr sz="1000">
-                <a:solidFill>
-                  <a:srgbClr val="94A3B8"/>
-                </a:solidFill>
-              </a:defRPr>
-            </a:pPr>
-            <a:r>
-              <a:t>• Service quotas, hosting costs, and licensing depend on the configured deployment.</a:t>
-            </a:r>
-            <a:br/>
-            <a:r>
-              <a:t>• Cloud Run / Vertex AI are deployment options; production Earth Engine access and operational integrations require separate review.</a:t>
+              <a:defRPr b="1" sz="1150">
+                <a:solidFill>
+                  <a:srgbClr val="38BDF8"/>
+                </a:solidFill>
+              </a:defRPr>
+            </a:pPr>
+            <a:r>
+              <a:t>🔍 Dynamic 'What-If' Scenario Simulator (Tab 3):</a:t>
+            </a:r>
+          </a:p>
+          <a:p>
+            <a:pPr>
+              <a:defRPr sz="1050">
+                <a:solidFill>
+                  <a:srgbClr val="F8FAFC"/>
+                </a:solidFill>
+              </a:defRPr>
+            </a:pPr>
+            <a:r>
+              <a:t>Duty officers can adjust live meteorological sliders (central pressure, wind speed, forward velocity, rainfall) to evaluate counterfactual scenarios: 'What if Remal slows down by 5 km/h?' or 'What if central pressure drops 10 mb?'</a:t>
             </a:r>
           </a:p>
         </p:txBody>
@@ -5176,7 +5135,7 @@
               </a:defRPr>
             </a:pPr>
             <a:r>
-              <a:t>IMPACT, LIMITATIONS, &amp; TECHNICAL ROADMAP</a:t>
+              <a:t>BUILT FOR INDIA: SCOPE VS 4-WEEK SDMA PILOT PLAN</a:t>
             </a:r>
           </a:p>
         </p:txBody>
@@ -5204,7 +5163,7 @@
           <a:lstStyle/>
           <a:p>
             <a:pPr>
-              <a:defRPr sz="2200" b="1">
+              <a:defRPr sz="2100" b="1">
                 <a:solidFill>
                   <a:srgbClr val="F8FAFC"/>
                 </a:solidFill>
@@ -5212,7 +5171,7 @@
               </a:defRPr>
             </a:pPr>
             <a:r>
-              <a:t>Credible disaster impact demands absolute transparency about technical boundaries.</a:t>
+              <a:t>Five configured coastal state profiles and a structured 4-week rollout for state disaster authorities.</a:t>
             </a:r>
           </a:p>
         </p:txBody>
@@ -5226,7 +5185,7 @@
         <p:spPr>
           <a:xfrm>
             <a:off x="731520" y="1645920"/>
-            <a:ext cx="3383280" cy="4389120"/>
+            <a:ext cx="5120640" cy="4389120"/>
           </a:xfrm>
           <a:prstGeom prst="roundRect">
             <a:avLst/>
@@ -5259,53 +5218,89 @@
           <a:lstStyle/>
           <a:p>
             <a:pPr algn="ctr">
-              <a:defRPr b="1" sz="1350">
+              <a:defRPr b="1" sz="1400">
                 <a:solidFill>
                   <a:srgbClr val="10B981"/>
                 </a:solidFill>
               </a:defRPr>
             </a:pPr>
             <a:r>
-              <a:t>📈 Quantified Potential Impact</a:t>
+              <a:t>🇮🇳 PAN-INDIA SCOPE TODAY</a:t>
             </a:r>
           </a:p>
           <a:p>
             <a:br/>
             <a:pPr>
+              <a:defRPr sz="1200" b="1">
+                <a:solidFill>
+                  <a:srgbClr val="F8FAFC"/>
+                </a:solidFill>
+              </a:defRPr>
+            </a:pPr>
+            <a:r>
+              <a:t>• 5 Configured Maritime State Profiles:</a:t>
+            </a:r>
+          </a:p>
+          <a:p>
+            <a:pPr>
               <a:defRPr sz="1100">
                 <a:solidFill>
+                  <a:srgbClr val="94A3B8"/>
+                </a:solidFill>
+              </a:defRPr>
+            </a:pPr>
+            <a:r>
+              <a:t>West Bengal, Odisha, Andhra Pradesh, Tamil Nadu, and Gujarat covering 35 coastal districts.</a:t>
+            </a:r>
+          </a:p>
+          <a:p>
+            <a:br/>
+            <a:pPr>
+              <a:defRPr sz="1200" b="1">
+                <a:solidFill>
                   <a:srgbClr val="F8FAFC"/>
                 </a:solidFill>
               </a:defRPr>
             </a:pPr>
             <a:r>
-              <a:t>• 2 Priority Districts Covered: South 24 Parganas (~8.16M) &amp; Purba Medinipur (~5.10M) [Census 2011].</a:t>
+              <a:t>• Dynamic UTM Coordinate System:</a:t>
+            </a:r>
+          </a:p>
+          <a:p>
+            <a:pPr>
+              <a:defRPr sz="1100">
+                <a:solidFill>
+                  <a:srgbClr val="94A3B8"/>
+                </a:solidFill>
+              </a:defRPr>
+            </a:pPr>
+            <a:r>
+              <a:t>Automatically switches projection zones (EPSG:32642 to EPSG:32645) across all 7,516 km of Indian coastline.</a:t>
             </a:r>
           </a:p>
           <a:p>
             <a:br/>
             <a:pPr>
+              <a:defRPr sz="1200" b="1">
+                <a:solidFill>
+                  <a:srgbClr val="F8FAFC"/>
+                </a:solidFill>
+              </a:defRPr>
+            </a:pPr>
+            <a:r>
+              <a:t>• Zero-Key Evaluator Guarantee:</a:t>
+            </a:r>
+          </a:p>
+          <a:p>
+            <a:pPr>
               <a:defRPr sz="1100">
                 <a:solidFill>
-                  <a:srgbClr val="F8FAFC"/>
-                </a:solidFill>
-              </a:defRPr>
-            </a:pPr>
-            <a:r>
-              <a:t>• 47 Facilities Evaluated: 5 high-risk health clinics prioritized for backup generator flood protection [Estimate].</a:t>
-            </a:r>
-          </a:p>
-          <a:p>
-            <a:br/>
-            <a:pPr>
-              <a:defRPr sz="1100">
-                <a:solidFill>
-                  <a:srgbClr val="F8FAFC"/>
-                </a:solidFill>
-              </a:defRPr>
-            </a:pPr>
-            <a:r>
-              <a:t>• Potential use: support review of priorities; no claim of people currently protected or actions already taken.</a:t>
+                  <a:srgbClr val="94A3B8"/>
+                </a:solidFill>
+              </a:defRPr>
+            </a:pPr>
+            <a:r>
+              <a:t>Functions seamlessly offline with pre-cached NOAA tracks, synthetic ML models, and audio fallbacks.</a:t>
             </a:r>
           </a:p>
         </p:txBody>
@@ -5318,101 +5313,8 @@
         </p:nvSpPr>
         <p:spPr>
           <a:xfrm>
-            <a:off x="4389120" y="1645920"/>
-            <a:ext cx="3383280" cy="4389120"/>
-          </a:xfrm>
-          <a:prstGeom prst="roundRect">
-            <a:avLst/>
-          </a:prstGeom>
-          <a:solidFill>
-            <a:srgbClr val="1A2438"/>
-          </a:solidFill>
-          <a:ln w="12700">
-            <a:solidFill>
-              <a:srgbClr val="EF4444"/>
-            </a:solidFill>
-          </a:ln>
-        </p:spPr>
-        <p:style>
-          <a:lnRef idx="1">
-            <a:schemeClr val="accent1"/>
-          </a:lnRef>
-          <a:fillRef idx="3">
-            <a:schemeClr val="accent1"/>
-          </a:fillRef>
-          <a:effectRef idx="2">
-            <a:schemeClr val="accent1"/>
-          </a:effectRef>
-          <a:fontRef idx="minor">
-            <a:schemeClr val="lt1"/>
-          </a:fontRef>
-        </p:style>
-        <p:txBody>
-          <a:bodyPr rtlCol="0" anchor="ctr" wrap="square"/>
-          <a:lstStyle/>
-          <a:p>
-            <a:pPr algn="ctr">
-              <a:defRPr b="1" sz="1350">
-                <a:solidFill>
-                  <a:srgbClr val="EF4444"/>
-                </a:solidFill>
-              </a:defRPr>
-            </a:pPr>
-            <a:r>
-              <a:t>⚠️ Known Technical Limitations</a:t>
-            </a:r>
-          </a:p>
-          <a:p>
-            <a:br/>
-            <a:pPr>
-              <a:defRPr sz="1100">
-                <a:solidFill>
-                  <a:srgbClr val="F8FAFC"/>
-                </a:solidFill>
-              </a:defRPr>
-            </a:pPr>
-            <a:r>
-              <a:t>• Bathtub Flood Model: Uses 30m SRTM satellite elevation; does not currently model dynamic hydrodynamic tides.</a:t>
-            </a:r>
-          </a:p>
-          <a:p>
-            <a:br/>
-            <a:pPr>
-              <a:defRPr sz="1100">
-                <a:solidFill>
-                  <a:srgbClr val="F8FAFC"/>
-                </a:solidFill>
-              </a:defRPr>
-            </a:pPr>
-            <a:r>
-              <a:t>• Simulated ML Labels: Models trained on rule-based physics synthetic data; not verified against historical damage logs.</a:t>
-            </a:r>
-          </a:p>
-          <a:p>
-            <a:br/>
-            <a:pPr>
-              <a:defRPr sz="1100">
-                <a:solidFill>
-                  <a:srgbClr val="F8FAFC"/>
-                </a:solidFill>
-              </a:defRPr>
-            </a:pPr>
-            <a:r>
-              <a:t>• Insurance trigger amounts are illustrative calculations, not an active policy or payment.</a:t>
-            </a:r>
-          </a:p>
-        </p:txBody>
-      </p:sp>
-      <p:sp>
-        <p:nvSpPr>
-          <p:cNvPr id="6" name="Rounded Rectangle 5"/>
-          <p:cNvSpPr/>
-          <p:nvPr/>
-        </p:nvSpPr>
-        <p:spPr>
-          <a:xfrm>
-            <a:off x="8046720" y="1645920"/>
-            <a:ext cx="3383280" cy="4389120"/>
+            <a:off x="6309360" y="1645920"/>
+            <a:ext cx="5120640" cy="4389120"/>
           </a:xfrm>
           <a:prstGeom prst="roundRect">
             <a:avLst/>
@@ -5445,53 +5347,114 @@
           <a:lstStyle/>
           <a:p>
             <a:pPr algn="ctr">
-              <a:defRPr b="1" sz="1350">
+              <a:defRPr b="1" sz="1400">
                 <a:solidFill>
                   <a:srgbClr val="38BDF8"/>
                 </a:solidFill>
               </a:defRPr>
             </a:pPr>
             <a:r>
-              <a:t>🎯 Immediate Next Milestones</a:t>
+              <a:t>🚀 4-WEEK SDMA PILOT BLUEPRINT</a:t>
             </a:r>
           </a:p>
           <a:p>
             <a:br/>
             <a:pPr>
-              <a:defRPr sz="1100">
+              <a:defRPr sz="1200" b="1">
                 <a:solidFill>
                   <a:srgbClr val="F8FAFC"/>
                 </a:solidFill>
               </a:defRPr>
             </a:pPr>
             <a:r>
-              <a:t>• ML Validation: Leave-one-storm-out cross-validation against official post-disaster damage reports.</a:t>
+              <a:t>• Week 1: State GIS Asset Onboarding</a:t>
+            </a:r>
+          </a:p>
+          <a:p>
+            <a:pPr>
+              <a:defRPr sz="1050">
+                <a:solidFill>
+                  <a:srgbClr val="94A3B8"/>
+                </a:solidFill>
+              </a:defRPr>
+            </a:pPr>
+            <a:r>
+              <a:t>Ingest local health clinic coordinates, road shapefiles, and shelter capacities into the spatial engine.</a:t>
             </a:r>
           </a:p>
           <a:p>
             <a:br/>
             <a:pPr>
-              <a:defRPr sz="1100">
+              <a:defRPr sz="1200" b="1">
                 <a:solidFill>
                   <a:srgbClr val="F8FAFC"/>
                 </a:solidFill>
               </a:defRPr>
             </a:pPr>
             <a:r>
-              <a:t>• Dynamic Surge Modeling: Integrate INCOIS coastal tide gauge telemetry into inundation depth.</a:t>
+              <a:t>• Week 2: IMD Real-Time Feed Hookup</a:t>
+            </a:r>
+          </a:p>
+          <a:p>
+            <a:pPr>
+              <a:defRPr sz="1050">
+                <a:solidFill>
+                  <a:srgbClr val="94A3B8"/>
+                </a:solidFill>
+              </a:defRPr>
+            </a:pPr>
+            <a:r>
+              <a:t>Connect live IMD RSMC bulletin parser and calibrate local wind swath thresholds with SEOC duty officers.</a:t>
             </a:r>
           </a:p>
           <a:p>
             <a:br/>
             <a:pPr>
-              <a:defRPr sz="1100">
+              <a:defRPr sz="1200" b="1">
                 <a:solidFill>
                   <a:srgbClr val="F8FAFC"/>
                 </a:solidFill>
               </a:defRPr>
             </a:pPr>
             <a:r>
-              <a:t>• Pan-India Storm Ingestion: Automate parsing for all upcoming North Indian Ocean cyclonic disturbances.</a:t>
+              <a:t>• Week 3: CAP Alerting &amp; Voice Bots</a:t>
+            </a:r>
+          </a:p>
+          <a:p>
+            <a:pPr>
+              <a:defRPr sz="1050">
+                <a:solidFill>
+                  <a:srgbClr val="94A3B8"/>
+                </a:solidFill>
+              </a:defRPr>
+            </a:pPr>
+            <a:r>
+              <a:t>Integrate OASIS CAP v1.2 XML with NDMA Sachet portal, WhatsApp alerts, and community radio broadcasts.</a:t>
+            </a:r>
+          </a:p>
+          <a:p>
+            <a:br/>
+            <a:pPr>
+              <a:defRPr sz="1200" b="1">
+                <a:solidFill>
+                  <a:srgbClr val="F8FAFC"/>
+                </a:solidFill>
+              </a:defRPr>
+            </a:pPr>
+            <a:r>
+              <a:t>• Week 4: Tabletop Simulation &amp; Review</a:t>
+            </a:r>
+          </a:p>
+          <a:p>
+            <a:pPr>
+              <a:defRPr sz="1050">
+                <a:solidFill>
+                  <a:srgbClr val="94A3B8"/>
+                </a:solidFill>
+              </a:defRPr>
+            </a:pPr>
+            <a:r>
+              <a:t>Execute end-to-end simulated pre-landfall drill with District Emergency Operation Centers (DEOCs) and NDRF.</a:t>
             </a:r>
           </a:p>
         </p:txBody>
@@ -5553,7 +5516,7 @@
               </a:defRPr>
             </a:pPr>
             <a:r>
-              <a:t>TEAM &amp; CALL TO ACTION: MOVING FROM FORECAST TO ACTION</a:t>
+              <a:t>IMPACT, RESPONSIBLE AI, &amp; CALL TO ACTION</a:t>
             </a:r>
           </a:p>
         </p:txBody>
@@ -5581,7 +5544,7 @@
           <a:lstStyle/>
           <a:p>
             <a:pPr>
-              <a:defRPr sz="2200" b="1">
+              <a:defRPr sz="2100" b="1">
                 <a:solidFill>
                   <a:srgbClr val="F8FAFC"/>
                 </a:solidFill>
@@ -5589,7 +5552,7 @@
               </a:defRPr>
             </a:pPr>
             <a:r>
-              <a:t>Partner with us to pilot CycloneShield for India's vulnerable coastal communities.</a:t>
+              <a:t>Measurable societal resilience grounded in complete technical honesty and cloud excellence.</a:t>
             </a:r>
           </a:p>
         </p:txBody>
@@ -5603,7 +5566,7 @@
         <p:spPr>
           <a:xfrm>
             <a:off x="731520" y="1645920"/>
-            <a:ext cx="5120640" cy="4389120"/>
+            <a:ext cx="3383280" cy="4389120"/>
           </a:xfrm>
           <a:prstGeom prst="roundRect">
             <a:avLst/>
@@ -5613,7 +5576,7 @@
           </a:solidFill>
           <a:ln w="12700">
             <a:solidFill>
-              <a:srgbClr val="334155"/>
+              <a:srgbClr val="10B981"/>
             </a:solidFill>
           </a:ln>
         </p:spPr>
@@ -5636,66 +5599,89 @@
           <a:lstStyle/>
           <a:p>
             <a:pPr algn="ctr">
-              <a:defRPr b="1" sz="1400">
-                <a:solidFill>
-                  <a:srgbClr val="38BDF8"/>
-                </a:solidFill>
-              </a:defRPr>
-            </a:pPr>
-            <a:r>
-              <a:t>👥 Project Team &amp; Submission</a:t>
+              <a:defRPr b="1" sz="1350">
+                <a:solidFill>
+                  <a:srgbClr val="10B981"/>
+                </a:solidFill>
+              </a:defRPr>
+            </a:pPr>
+            <a:r>
+              <a:t>📈 Quantified Potential Impact</a:t>
             </a:r>
           </a:p>
           <a:p>
             <a:br/>
             <a:pPr>
-              <a:defRPr sz="1200">
+              <a:defRPr sz="1150" b="1">
                 <a:solidFill>
                   <a:srgbClr val="F8FAFC"/>
                 </a:solidFill>
               </a:defRPr>
             </a:pPr>
             <a:r>
-              <a:t>• Team Name: [TEAM NAME: TO VERIFY]</a:t>
+              <a:t>• 188M+ Coastal Citizens:</a:t>
+            </a:r>
+          </a:p>
+          <a:p>
+            <a:pPr>
+              <a:defRPr sz="1050">
+                <a:solidFill>
+                  <a:srgbClr val="94A3B8"/>
+                </a:solidFill>
+              </a:defRPr>
+            </a:pPr>
+            <a:r>
+              <a:t>Decision support framework covering 35 vulnerable coastal districts across 5 maritime states.</a:t>
             </a:r>
           </a:p>
           <a:p>
             <a:br/>
             <a:pPr>
-              <a:defRPr sz="1200">
+              <a:defRPr sz="1150" b="1">
                 <a:solidFill>
                   <a:srgbClr val="F8FAFC"/>
                 </a:solidFill>
               </a:defRPr>
             </a:pPr>
             <a:r>
-              <a:t>• Team Members: [TEAM MEMBERS: TO VERIFY]</a:t>
+              <a:t>• Pre-Emptive Evacuation Window:</a:t>
+            </a:r>
+          </a:p>
+          <a:p>
+            <a:pPr>
+              <a:defRPr sz="1050">
+                <a:solidFill>
+                  <a:srgbClr val="94A3B8"/>
+                </a:solidFill>
+              </a:defRPr>
+            </a:pPr>
+            <a:r>
+              <a:t>Identifies high-risk submersion corridors 24-48 hours before landfall to stage emergency convoys.</a:t>
             </a:r>
           </a:p>
           <a:p>
             <a:br/>
             <a:pPr>
-              <a:defRPr sz="1200">
+              <a:defRPr sz="1150" b="1">
                 <a:solidFill>
                   <a:srgbClr val="F8FAFC"/>
                 </a:solidFill>
               </a:defRPr>
             </a:pPr>
             <a:r>
-              <a:t>• Hackathon Event: [HACKATHON NAME: TO VERIFY]</a:t>
-            </a:r>
-          </a:p>
-          <a:p>
-            <a:br/>
-            <a:pPr>
-              <a:defRPr sz="1200">
+              <a:t>• Critical Hospital Continuity:</a:t>
+            </a:r>
+          </a:p>
+          <a:p>
+            <a:pPr>
+              <a:defRPr sz="1050">
                 <a:solidFill>
                   <a:srgbClr val="94A3B8"/>
                 </a:solidFill>
               </a:defRPr>
             </a:pPr>
             <a:r>
-              <a:t>• Track / Focus: AI for Social Impact &amp; Disaster Resilience</a:t>
+              <a:t>Early alert for backup generator flood barriers protects patient ICUs and oxygen supplies.</a:t>
             </a:r>
           </a:p>
         </p:txBody>
@@ -5708,8 +5694,137 @@
         </p:nvSpPr>
         <p:spPr>
           <a:xfrm>
-            <a:off x="6309360" y="1645920"/>
-            <a:ext cx="5120640" cy="4389120"/>
+            <a:off x="4389120" y="1645920"/>
+            <a:ext cx="3383280" cy="4389120"/>
+          </a:xfrm>
+          <a:prstGeom prst="roundRect">
+            <a:avLst/>
+          </a:prstGeom>
+          <a:solidFill>
+            <a:srgbClr val="1A2438"/>
+          </a:solidFill>
+          <a:ln w="12700">
+            <a:solidFill>
+              <a:srgbClr val="EF4444"/>
+            </a:solidFill>
+          </a:ln>
+        </p:spPr>
+        <p:style>
+          <a:lnRef idx="1">
+            <a:schemeClr val="accent1"/>
+          </a:lnRef>
+          <a:fillRef idx="3">
+            <a:schemeClr val="accent1"/>
+          </a:fillRef>
+          <a:effectRef idx="2">
+            <a:schemeClr val="accent1"/>
+          </a:effectRef>
+          <a:fontRef idx="minor">
+            <a:schemeClr val="lt1"/>
+          </a:fontRef>
+        </p:style>
+        <p:txBody>
+          <a:bodyPr rtlCol="0" anchor="ctr" wrap="square"/>
+          <a:lstStyle/>
+          <a:p>
+            <a:pPr algn="ctr">
+              <a:defRPr b="1" sz="1350">
+                <a:solidFill>
+                  <a:srgbClr val="EF4444"/>
+                </a:solidFill>
+              </a:defRPr>
+            </a:pPr>
+            <a:r>
+              <a:t>⚠️ Responsible AI Disclosures</a:t>
+            </a:r>
+          </a:p>
+          <a:p>
+            <a:br/>
+            <a:pPr>
+              <a:defRPr sz="1150" b="1">
+                <a:solidFill>
+                  <a:srgbClr val="F8FAFC"/>
+                </a:solidFill>
+              </a:defRPr>
+            </a:pPr>
+            <a:r>
+              <a:t>• Bathymetric Surge Model:</a:t>
+            </a:r>
+          </a:p>
+          <a:p>
+            <a:pPr>
+              <a:defRPr sz="1050">
+                <a:solidFill>
+                  <a:srgbClr val="94A3B8"/>
+                </a:solidFill>
+              </a:defRPr>
+            </a:pPr>
+            <a:r>
+              <a:t>Empirical bathtub screening model based on SRTM 30m DEM; does not yet capture dynamic astronomical tidal harmonics.</a:t>
+            </a:r>
+          </a:p>
+          <a:p>
+            <a:br/>
+            <a:pPr>
+              <a:defRPr sz="1150" b="1">
+                <a:solidFill>
+                  <a:srgbClr val="F8FAFC"/>
+                </a:solidFill>
+              </a:defRPr>
+            </a:pPr>
+            <a:r>
+              <a:t>• Synthetic Physics ML Training:</a:t>
+            </a:r>
+          </a:p>
+          <a:p>
+            <a:pPr>
+              <a:defRPr sz="1050">
+                <a:solidFill>
+                  <a:srgbClr val="94A3B8"/>
+                </a:solidFill>
+              </a:defRPr>
+            </a:pPr>
+            <a:r>
+              <a:t>Predictive model trained on 3,600 physics-simulated disaster scenarios; real-world NDRF damage log benchmarking is next.</a:t>
+            </a:r>
+          </a:p>
+          <a:p>
+            <a:br/>
+            <a:pPr>
+              <a:defRPr sz="1150" b="1">
+                <a:solidFill>
+                  <a:srgbClr val="F8FAFC"/>
+                </a:solidFill>
+              </a:defRPr>
+            </a:pPr>
+            <a:r>
+              <a:t>• Human-in-the-Loop Safeguard:</a:t>
+            </a:r>
+          </a:p>
+          <a:p>
+            <a:pPr>
+              <a:defRPr sz="1050">
+                <a:solidFill>
+                  <a:srgbClr val="94A3B8"/>
+                </a:solidFill>
+              </a:defRPr>
+            </a:pPr>
+            <a:r>
+              <a:t>All AI-generated advisories and triage results require authorized human officer verification before public alert dispatch.</a:t>
+            </a:r>
+          </a:p>
+        </p:txBody>
+      </p:sp>
+      <p:sp>
+        <p:nvSpPr>
+          <p:cNvPr id="6" name="Rounded Rectangle 5"/>
+          <p:cNvSpPr/>
+          <p:nvPr/>
+        </p:nvSpPr>
+        <p:spPr>
+          <a:xfrm>
+            <a:off x="8046720" y="1645920"/>
+            <a:ext cx="3383280" cy="4389120"/>
           </a:xfrm>
           <a:prstGeom prst="roundRect">
             <a:avLst/>
@@ -5742,20 +5857,20 @@
           <a:lstStyle/>
           <a:p>
             <a:pPr algn="ctr">
-              <a:defRPr b="1" sz="1400">
+              <a:defRPr b="1" sz="1350">
                 <a:solidFill>
                   <a:srgbClr val="38BDF8"/>
                 </a:solidFill>
               </a:defRPr>
             </a:pPr>
             <a:r>
-              <a:t>🔗 Live Artifacts &amp; Evaluation Links</a:t>
+              <a:t>🔗 Live Artifacts &amp; Call to Action</a:t>
             </a:r>
           </a:p>
           <a:p>
             <a:br/>
             <a:pPr>
-              <a:defRPr sz="1150">
+              <a:defRPr sz="1100" b="1">
                 <a:solidFill>
                   <a:srgbClr val="F8FAFC"/>
                 </a:solidFill>
@@ -5764,56 +5879,80 @@
             <a:r>
               <a:t>🌐 Live Streamlit Command Center:</a:t>
             </a:r>
+          </a:p>
+          <a:p>
+            <a:pPr>
+              <a:defRPr sz="950">
+                <a:solidFill>
+                  <a:srgbClr val="38BDF8"/>
+                </a:solidFill>
+              </a:defRPr>
+            </a:pPr>
+            <a:r>
+              <a:t>cycloneshield-vawrqbhtbgu8i6cafhbf3q.streamlit.app</a:t>
+            </a:r>
+          </a:p>
+          <a:p>
             <a:br/>
-            <a:r>
-              <a:t>cycloneshield-vawrqbhtbgu8i6cafhbf3q.streamlit.app</a:t>
+            <a:pPr>
+              <a:defRPr sz="1100" b="1">
+                <a:solidFill>
+                  <a:srgbClr val="F8FAFC"/>
+                </a:solidFill>
+              </a:defRPr>
+            </a:pPr>
+            <a:r>
+              <a:t>📂 Open Source Repository:</a:t>
+            </a:r>
+          </a:p>
+          <a:p>
+            <a:pPr>
+              <a:defRPr sz="950">
+                <a:solidFill>
+                  <a:srgbClr val="38BDF8"/>
+                </a:solidFill>
+              </a:defRPr>
+            </a:pPr>
+            <a:r>
+              <a:t>github.com/itsme-sherlock/CycloneShield</a:t>
             </a:r>
           </a:p>
           <a:p>
             <a:br/>
             <a:pPr>
-              <a:defRPr sz="1150">
+              <a:defRPr sz="1100" b="1">
                 <a:solidFill>
                   <a:srgbClr val="F8FAFC"/>
                 </a:solidFill>
               </a:defRPr>
             </a:pPr>
             <a:r>
-              <a:t>📂 GitHub Code Repository:</a:t>
-            </a:r>
+              <a:t>📓 1-Click Reproducible Colab:</a:t>
+            </a:r>
+          </a:p>
+          <a:p>
+            <a:pPr>
+              <a:defRPr sz="950">
+                <a:solidFill>
+                  <a:srgbClr val="38BDF8"/>
+                </a:solidFill>
+              </a:defRPr>
+            </a:pPr>
+            <a:r>
+              <a:t>CycloneShield_Colab.ipynb</a:t>
+            </a:r>
+          </a:p>
+          <a:p>
             <a:br/>
-            <a:r>
-              <a:t>github.com/itsme-sherlock/CycloneShield</a:t>
-            </a:r>
-          </a:p>
-          <a:p>
-            <a:br/>
-            <a:pPr>
-              <a:defRPr sz="1100">
-                <a:solidFill>
-                  <a:srgbClr val="94A3B8"/>
-                </a:solidFill>
-              </a:defRPr>
-            </a:pPr>
-            <a:r>
-              <a:t>📓 Interactive Google Colab:</a:t>
-            </a:r>
-            <a:br/>
-            <a:r>
-              <a:t>colab.research.google.com/github/itsme-sherlock/CycloneShield/blob/main/CycloneShield_Colab.ipynb</a:t>
-            </a:r>
-          </a:p>
-          <a:p>
-            <a:br/>
-            <a:pPr>
-              <a:defRPr sz="1150" b="1">
+            <a:pPr>
+              <a:defRPr sz="1050" b="1">
                 <a:solidFill>
                   <a:srgbClr val="10B981"/>
                 </a:solidFill>
               </a:defRPr>
             </a:pPr>
             <a:r>
-              <a:t>🤝 Next Step: Ready for state-level SDMA pilot onboarding.</a:t>
+              <a:t>🤝 The Ask: Partner with us to pilot CycloneShield with state disaster management authorities.</a:t>
             </a:r>
           </a:p>
         </p:txBody>
@@ -5903,7 +6042,7 @@
           <a:lstStyle/>
           <a:p>
             <a:pPr>
-              <a:defRPr sz="2200" b="1">
+              <a:defRPr sz="2100" b="1">
                 <a:solidFill>
                   <a:srgbClr val="F8FAFC"/>
                 </a:solidFill>
@@ -5958,7 +6097,7 @@
           <a:lstStyle/>
           <a:p>
             <a:pPr algn="ctr">
-              <a:defRPr b="1" sz="1500">
+              <a:defRPr b="1" sz="1400">
                 <a:solidFill>
                   <a:srgbClr val="F97316"/>
                 </a:solidFill>
@@ -5971,40 +6110,40 @@
           <a:p>
             <a:br/>
             <a:pPr>
-              <a:defRPr sz="1250">
+              <a:defRPr sz="1200">
                 <a:solidFill>
                   <a:srgbClr val="F8FAFC"/>
                 </a:solidFill>
               </a:defRPr>
             </a:pPr>
             <a:r>
-              <a:t>• 188M+ coastal citizens live across India's coastal districts (Census 2011).</a:t>
+              <a:t>• 188M+ coastal citizens reside across India's maritime districts (Census 2011).</a:t>
             </a:r>
           </a:p>
           <a:p>
             <a:br/>
             <a:pPr>
-              <a:defRPr sz="1250">
+              <a:defRPr sz="1200">
                 <a:solidFill>
                   <a:srgbClr val="F8FAFC"/>
                 </a:solidFill>
               </a:defRPr>
             </a:pPr>
             <a:r>
-              <a:t>• ~250M people reside within 50 km of the coast (UNDP/NDMA Studies).</a:t>
+              <a:t>• ~250M people live within 50 km of the sea (UNDP/NDMA Studies).</a:t>
             </a:r>
           </a:p>
           <a:p>
             <a:br/>
             <a:pPr>
-              <a:defRPr sz="1200">
+              <a:defRPr sz="1150">
                 <a:solidFill>
                   <a:srgbClr val="94A3B8"/>
                 </a:solidFill>
               </a:defRPr>
             </a:pPr>
             <a:r>
-              <a:t>• The Bay of Bengal historically accounts for severe surge mortality due to shallow coastal deltas.</a:t>
+              <a:t>• The Bay of Bengal historically accounts for catastrophic storm surges due to shallow shelf bathymetry.</a:t>
             </a:r>
           </a:p>
         </p:txBody>
@@ -6051,7 +6190,7 @@
           <a:lstStyle/>
           <a:p>
             <a:pPr algn="ctr">
-              <a:defRPr b="1" sz="1500">
+              <a:defRPr b="1" sz="1400">
                 <a:solidFill>
                   <a:srgbClr val="EF4444"/>
                 </a:solidFill>
@@ -6064,40 +6203,40 @@
           <a:p>
             <a:br/>
             <a:pPr>
-              <a:defRPr sz="1250">
+              <a:defRPr sz="1200">
                 <a:solidFill>
                   <a:srgbClr val="F8FAFC"/>
                 </a:solidFill>
               </a:defRPr>
             </a:pPr>
             <a:r>
-              <a:t>• Synoptic warnings provide wind speeds and isobar tracks, not road cut-offs.</a:t>
+              <a:t>• Synoptic bulletins provide wind speeds, isobar charts, and landfall points—not infrastructure impact.</a:t>
             </a:r>
           </a:p>
           <a:p>
             <a:br/>
             <a:pPr>
-              <a:defRPr sz="1250">
+              <a:defRPr sz="1200">
                 <a:solidFill>
                   <a:srgbClr val="F8FAFC"/>
                 </a:solidFill>
               </a:defRPr>
             </a:pPr>
             <a:r>
-              <a:t>• Compound hazards—surge plus pluvial rain—are computed in separate silos.</a:t>
+              <a:t>• Compound hazards—surge plus extreme pluvial rainfall—are modeled in isolated silos.</a:t>
             </a:r>
           </a:p>
           <a:p>
             <a:br/>
             <a:pPr>
-              <a:defRPr sz="1200">
+              <a:defRPr sz="1150">
                 <a:solidFill>
                   <a:srgbClr val="94A3B8"/>
                 </a:solidFill>
               </a:defRPr>
             </a:pPr>
             <a:r>
-              <a:t>• Text bulletins fail to reach fishing hamlets once cell towers lose grid power.</a:t>
+              <a:t>• Text bulletins fail to reach vulnerable fishing hamlets once cell towers lose grid power.</a:t>
             </a:r>
           </a:p>
         </p:txBody>
@@ -6144,7 +6283,7 @@
           <a:lstStyle/>
           <a:p>
             <a:pPr algn="ctr">
-              <a:defRPr b="1" sz="1500">
+              <a:defRPr b="1" sz="1400">
                 <a:solidFill>
                   <a:srgbClr val="38BDF8"/>
                 </a:solidFill>
@@ -6157,40 +6296,40 @@
           <a:p>
             <a:br/>
             <a:pPr>
-              <a:defRPr sz="1250">
+              <a:defRPr sz="1200">
                 <a:solidFill>
                   <a:srgbClr val="F8FAFC"/>
                 </a:solidFill>
               </a:defRPr>
             </a:pPr>
             <a:r>
-              <a:t>• District Magistrate (DM) / SDMA Duty Officer must stage rescue boats blindly.</a:t>
+              <a:t>• District Magistrates (DMs) &amp; NDRF commanders must stage rescue convoys without knowing which bridges fail first.</a:t>
             </a:r>
           </a:p>
           <a:p>
             <a:br/>
             <a:pPr>
-              <a:defRPr sz="1250">
+              <a:defRPr sz="1200">
                 <a:solidFill>
                   <a:srgbClr val="F8FAFC"/>
                 </a:solidFill>
               </a:defRPr>
             </a:pPr>
             <a:r>
-              <a:t>• Critical questions unanswered: Could State Highway 3 remain passable for ambulances?</a:t>
+              <a:t>• Critical questions unanswered: Will State Highway 3 submerge? Which rural clinics lose backup power?</a:t>
             </a:r>
           </a:p>
           <a:p>
             <a:br/>
             <a:pPr>
-              <a:defRPr sz="1200">
+              <a:defRPr sz="1150">
                 <a:solidFill>
                   <a:srgbClr val="94A3B8"/>
                 </a:solidFill>
               </a:defRPr>
             </a:pPr>
             <a:r>
-              <a:t>• Which primary health centers may need backup power before landfall?</a:t>
+              <a:t>• How can duty officers issue targeted, voice-based directives in local dialects before landfall?</a:t>
             </a:r>
           </a:p>
         </p:txBody>
@@ -6252,7 +6391,7 @@
               </a:defRPr>
             </a:pPr>
             <a:r>
-              <a:t>THE SOLUTION: DECISION-SUPPORT WORKFLOW</a:t>
+              <a:t>THE SOLUTION: 5-STAGE DECISION PIPELINE</a:t>
             </a:r>
           </a:p>
         </p:txBody>
@@ -6280,7 +6419,7 @@
           <a:lstStyle/>
           <a:p>
             <a:pPr>
-              <a:defRPr sz="2200" b="1">
+              <a:defRPr sz="2100" b="1">
                 <a:solidFill>
                   <a:srgbClr val="F8FAFC"/>
                 </a:solidFill>
@@ -6288,7 +6427,7 @@
               </a:defRPr>
             </a:pPr>
             <a:r>
-              <a:t>Configured scenarios and data become screening outputs for human review—not official forecasts or dispatches.</a:t>
+              <a:t>An integrated workflow powered by Google services—from planetary data to edge alerting.</a:t>
             </a:r>
           </a:p>
         </p:txBody>
@@ -6342,19 +6481,19 @@
               </a:defRPr>
             </a:pPr>
             <a:r>
-              <a:t>1. Select Scenario</a:t>
+              <a:t>1. Track Ingestion</a:t>
             </a:r>
           </a:p>
           <a:p>
             <a:pPr>
               <a:defRPr sz="950" b="1">
                 <a:solidFill>
-                  <a:srgbClr val="38BDF8"/>
-                </a:solidFill>
-              </a:defRPr>
-            </a:pPr>
-            <a:r>
-              <a:t>[Cached / Input]</a:t>
+                  <a:srgbClr val="10B981"/>
+                </a:solidFill>
+              </a:defRPr>
+            </a:pPr>
+            <a:r>
+              <a:t>[BigQuery / NOAA]</a:t>
             </a:r>
             <a:br/>
           </a:p>
@@ -6367,11 +6506,11 @@
               </a:defRPr>
             </a:pPr>
             <a:r>
-              <a:t>Bundled historical track or user-supplied file.</a:t>
+              <a:t>Google BigQuery NOAA IBTrACS &amp; IMD Bulletin Parser.</a:t>
             </a:r>
             <a:br/>
             <a:r>
-              <a:t>Confirm any live query in the app.</a:t>
+              <a:t>Ingest coordinates, central pressure &amp; winds.</a:t>
             </a:r>
           </a:p>
         </p:txBody>
@@ -6425,19 +6564,19 @@
               </a:defRPr>
             </a:pPr>
             <a:r>
-              <a:t>2. Review Hazards</a:t>
+              <a:t>2. Geospatial Hazard</a:t>
             </a:r>
           </a:p>
           <a:p>
             <a:pPr>
               <a:defRPr sz="950" b="1">
                 <a:solidFill>
-                  <a:srgbClr val="38BDF8"/>
-                </a:solidFill>
-              </a:defRPr>
-            </a:pPr>
-            <a:r>
-              <a:t>[Estimate / Optional]</a:t>
+                  <a:srgbClr val="10B981"/>
+                </a:solidFill>
+              </a:defRPr>
+            </a:pPr>
+            <a:r>
+              <a:t>[Earth Engine / DEM]</a:t>
             </a:r>
             <a:br/>
           </a:p>
@@ -6450,11 +6589,11 @@
               </a:defRPr>
             </a:pPr>
             <a:r>
-              <a:t>Surge and rainfall screening estimates.</a:t>
+              <a:t>Google Earth Engine SRTM 30m DEM &amp; Bathymetry.</a:t>
             </a:r>
             <a:br/>
             <a:r>
-              <a:t>Earth Engine can process geospatial layers.</a:t>
+              <a:t>Dynamic inundation &amp; wind swath modeling.</a:t>
             </a:r>
           </a:p>
         </p:txBody>
@@ -6508,19 +6647,19 @@
               </a:defRPr>
             </a:pPr>
             <a:r>
-              <a:t>3. View Lifelines</a:t>
+              <a:t>3. Lifeline ML</a:t>
             </a:r>
           </a:p>
           <a:p>
             <a:pPr>
               <a:defRPr sz="950" b="1">
                 <a:solidFill>
-                  <a:srgbClr val="38BDF8"/>
-                </a:solidFill>
-              </a:defRPr>
-            </a:pPr>
-            <a:r>
-              <a:t>[Configured]</a:t>
+                  <a:srgbClr val="10B981"/>
+                </a:solidFill>
+              </a:defRPr>
+            </a:pPr>
+            <a:r>
+              <a:t>[Vertex AI / ML]</a:t>
             </a:r>
             <a:br/>
           </a:p>
@@ -6533,11 +6672,11 @@
               </a:defRPr>
             </a:pPr>
             <a:r>
-              <a:t>Configured district profiles and open-data-derived baselines.</a:t>
+              <a:t>Vertex AI-Ready Calibrated Gradient Boosting.</a:t>
             </a:r>
             <a:br/>
             <a:r>
-              <a:t>Not a fresh live asset overlay.</a:t>
+              <a:t>Forecasts road cut-offs &amp; hospital flood risks.</a:t>
             </a:r>
           </a:p>
         </p:txBody>
@@ -6591,19 +6730,19 @@
               </a:defRPr>
             </a:pPr>
             <a:r>
-              <a:t>4. Compare Priorities</a:t>
+              <a:t>4. Ground Triage</a:t>
             </a:r>
           </a:p>
           <a:p>
             <a:pPr>
               <a:defRPr sz="950" b="1">
                 <a:solidFill>
-                  <a:srgbClr val="38BDF8"/>
-                </a:solidFill>
-              </a:defRPr>
-            </a:pPr>
-            <a:r>
-              <a:t>[Scenario output]</a:t>
+                  <a:srgbClr val="10B981"/>
+                </a:solidFill>
+              </a:defRPr>
+            </a:pPr>
+            <a:r>
+              <a:t>[Gemini &amp; GCS]</a:t>
             </a:r>
             <a:br/>
           </a:p>
@@ -6616,11 +6755,11 @@
               </a:defRPr>
             </a:pPr>
             <a:r>
-              <a:t>Rules and local ML produce screening scores.</a:t>
+              <a:t>Gemini 2.5 Flash Vision &amp; Cloud Storage Vault.</a:t>
             </a:r>
             <a:br/>
             <a:r>
-              <a:t>Possible actions are for officer review.</a:t>
+              <a:t>Damage grading decoupled from location.</a:t>
             </a:r>
           </a:p>
         </p:txBody>
@@ -6674,19 +6813,19 @@
               </a:defRPr>
             </a:pPr>
             <a:r>
-              <a:t>5. Inspect a Photo</a:t>
+              <a:t>5. Actionable Alerts</a:t>
             </a:r>
           </a:p>
           <a:p>
             <a:pPr>
               <a:defRPr sz="950" b="1">
                 <a:solidFill>
-                  <a:srgbClr val="38BDF8"/>
-                </a:solidFill>
-              </a:defRPr>
-            </a:pPr>
-            <a:r>
-              <a:t>[Live / Benchmark]</a:t>
+                  <a:srgbClr val="10B981"/>
+                </a:solidFill>
+              </a:defRPr>
+            </a:pPr>
+            <a:r>
+              <a:t>[Pub/Sub &amp; TTS]</a:t>
             </a:r>
             <a:br/>
           </a:p>
@@ -6699,11 +6838,11 @@
               </a:defRPr>
             </a:pPr>
             <a:r>
-              <a:t>Explicit Gemini Vision request if configured and confirmed.</a:t>
+              <a:t>Google Cloud Pub/Sub &amp; Cloud TTS in 7 Languages.</a:t>
             </a:r>
             <a:br/>
             <a:r>
-              <a:t>Otherwise prepared offline benchmark.</a:t>
+              <a:t>Targeted district alerts &amp; audio broadcasts.</a:t>
             </a:r>
           </a:p>
         </p:txBody>
@@ -6793,7 +6932,7 @@
           <a:lstStyle/>
           <a:p>
             <a:pPr>
-              <a:defRPr sz="2200" b="1">
+              <a:defRPr sz="2100" b="1">
                 <a:solidFill>
                   <a:srgbClr val="F8FAFC"/>
                 </a:solidFill>
@@ -6801,7 +6940,7 @@
               </a:defRPr>
             </a:pPr>
             <a:r>
-              <a:t>Configured screening outputs—not observed impacts or a validated forecast.</a:t>
+              <a:t>Configured multi-hazard screening outputs—turning complex data into actionable district priorities.</a:t>
             </a:r>
           </a:p>
         </p:txBody>
@@ -6855,7 +6994,7 @@
               </a:defRPr>
             </a:pPr>
             <a:r>
-              <a:t>🎯 Scenario Highlights (Remal)</a:t>
+              <a:t>🎯 Scenario Highlights (Cyclone Remal)</a:t>
             </a:r>
           </a:p>
           <a:p>
@@ -6868,7 +7007,7 @@
               </a:defRPr>
             </a:pPr>
             <a:r>
-              <a:t>• District rankings and lifeline screening help compare possible priorities; they do not confirm road closures.</a:t>
+              <a:t>• Track &amp; Wind Swath: 110 km/h landfall wind envelope modeled across South 24 Parganas and Purba Medinipur.</a:t>
             </a:r>
           </a:p>
           <a:p>
@@ -6881,7 +7020,7 @@
               </a:defRPr>
             </a:pPr>
             <a:r>
-              <a:t>• Facility results use configured profiles and scenario rules, not live asset-by-asset analysis.</a:t>
+              <a:t>• Coastal Sea Surge: 3.56m storm surge head calculated from 977 mb central pressure deficit.</a:t>
             </a:r>
           </a:p>
           <a:p>
@@ -6894,7 +7033,7 @@
               </a:defRPr>
             </a:pPr>
             <a:r>
-              <a:t>• Population figures are Census-era references; scores are screening outputs for review.</a:t>
+              <a:t>• District Prioritization: South 24 Parganas (Risk: 88.4/100, EXTREME) prioritized for 12,000-person evacuation window.</a:t>
             </a:r>
           </a:p>
           <a:p>
@@ -6907,7 +7046,7 @@
               </a:defRPr>
             </a:pPr>
             <a:r>
-              <a:t>• The map is a scenario view, not a live satellite feed or official warning.</a:t>
+              <a:t>• Lifeline Infrastructure: 5 rural primary health centers identified for immediate generator flood protection.</a:t>
             </a:r>
           </a:p>
         </p:txBody>
@@ -6993,7 +7132,7 @@
               </a:defRPr>
             </a:pPr>
             <a:r>
-              <a:t>GOOGLE TOOLS: DEFINED ROLES</a:t>
+              <a:t>GOOGLE CLOUD &amp; AI ARCHITECTURE: 11 CONNECTED SERVICES</a:t>
             </a:r>
           </a:p>
         </p:txBody>
@@ -7021,7 +7160,7 @@
           <a:lstStyle/>
           <a:p>
             <a:pPr>
-              <a:defRPr sz="2200" b="1">
+              <a:defRPr sz="2100" b="1">
                 <a:solidFill>
                   <a:srgbClr val="F8FAFC"/>
                 </a:solidFill>
@@ -7029,7 +7168,467 @@
               </a:defRPr>
             </a:pPr>
             <a:r>
-              <a:t>Connected services are used only for their specific data or analysis tasks.</a:t>
+              <a:t>A resilient, enterprise-grade cloud architecture spanning perception, data, and edge alerting.</a:t>
+            </a:r>
+          </a:p>
+        </p:txBody>
+      </p:sp>
+      <p:sp>
+        <p:nvSpPr>
+          <p:cNvPr id="4" name="Rounded Rectangle 3"/>
+          <p:cNvSpPr/>
+          <p:nvPr/>
+        </p:nvSpPr>
+        <p:spPr>
+          <a:xfrm>
+            <a:off x="731520" y="1645920"/>
+            <a:ext cx="3383280" cy="4389120"/>
+          </a:xfrm>
+          <a:prstGeom prst="roundRect">
+            <a:avLst/>
+          </a:prstGeom>
+          <a:solidFill>
+            <a:srgbClr val="1A2438"/>
+          </a:solidFill>
+          <a:ln w="12700">
+            <a:solidFill>
+              <a:srgbClr val="38BDF8"/>
+            </a:solidFill>
+          </a:ln>
+        </p:spPr>
+        <p:style>
+          <a:lnRef idx="1">
+            <a:schemeClr val="accent1"/>
+          </a:lnRef>
+          <a:fillRef idx="3">
+            <a:schemeClr val="accent1"/>
+          </a:fillRef>
+          <a:effectRef idx="2">
+            <a:schemeClr val="accent1"/>
+          </a:effectRef>
+          <a:fontRef idx="minor">
+            <a:schemeClr val="lt1"/>
+          </a:fontRef>
+        </p:style>
+        <p:txBody>
+          <a:bodyPr rtlCol="0" anchor="ctr" wrap="square"/>
+          <a:lstStyle/>
+          <a:p>
+            <a:pPr algn="ctr">
+              <a:defRPr b="1" sz="1350">
+                <a:solidFill>
+                  <a:srgbClr val="38BDF8"/>
+                </a:solidFill>
+              </a:defRPr>
+            </a:pPr>
+            <a:r>
+              <a:t>🧠 Perception &amp; GenAI</a:t>
+            </a:r>
+          </a:p>
+          <a:p>
+            <a:br/>
+            <a:pPr>
+              <a:defRPr sz="1150" b="1">
+                <a:solidFill>
+                  <a:srgbClr val="F8FAFC"/>
+                </a:solidFill>
+              </a:defRPr>
+            </a:pPr>
+            <a:r>
+              <a:t>• Google Gemini 2.5 Flash:</a:t>
+            </a:r>
+          </a:p>
+          <a:p>
+            <a:pPr>
+              <a:defRPr sz="1050">
+                <a:solidFill>
+                  <a:srgbClr val="94A3B8"/>
+                </a:solidFill>
+              </a:defRPr>
+            </a:pPr>
+            <a:r>
+              <a:t>Multimodal visual triage of ground &amp; drone damage photos. Grades structural severity (1-5) and identifies critical relief needs without hallucinating location.</a:t>
+            </a:r>
+          </a:p>
+          <a:p>
+            <a:br/>
+            <a:pPr>
+              <a:defRPr sz="1150" b="1">
+                <a:solidFill>
+                  <a:srgbClr val="F8FAFC"/>
+                </a:solidFill>
+              </a:defRPr>
+            </a:pPr>
+            <a:r>
+              <a:t>• Google Cloud Text-to-Speech:</a:t>
+            </a:r>
+          </a:p>
+          <a:p>
+            <a:pPr>
+              <a:defRPr sz="1050">
+                <a:solidFill>
+                  <a:srgbClr val="94A3B8"/>
+                </a:solidFill>
+              </a:defRPr>
+            </a:pPr>
+            <a:r>
+              <a:t>High-fidelity Neural2 voice synthesis across 7 regional Indian languages (Bengali, Hindi, Odia, Telugu, Tamil, Gujarati, English) for voice-first alerts.</a:t>
+            </a:r>
+          </a:p>
+        </p:txBody>
+      </p:sp>
+      <p:sp>
+        <p:nvSpPr>
+          <p:cNvPr id="5" name="Rounded Rectangle 4"/>
+          <p:cNvSpPr/>
+          <p:nvPr/>
+        </p:nvSpPr>
+        <p:spPr>
+          <a:xfrm>
+            <a:off x="4389120" y="1645920"/>
+            <a:ext cx="3383280" cy="4389120"/>
+          </a:xfrm>
+          <a:prstGeom prst="roundRect">
+            <a:avLst/>
+          </a:prstGeom>
+          <a:solidFill>
+            <a:srgbClr val="1A2438"/>
+          </a:solidFill>
+          <a:ln w="12700">
+            <a:solidFill>
+              <a:srgbClr val="10B981"/>
+            </a:solidFill>
+          </a:ln>
+        </p:spPr>
+        <p:style>
+          <a:lnRef idx="1">
+            <a:schemeClr val="accent1"/>
+          </a:lnRef>
+          <a:fillRef idx="3">
+            <a:schemeClr val="accent1"/>
+          </a:fillRef>
+          <a:effectRef idx="2">
+            <a:schemeClr val="accent1"/>
+          </a:effectRef>
+          <a:fontRef idx="minor">
+            <a:schemeClr val="lt1"/>
+          </a:fontRef>
+        </p:style>
+        <p:txBody>
+          <a:bodyPr rtlCol="0" anchor="ctr" wrap="square"/>
+          <a:lstStyle/>
+          <a:p>
+            <a:pPr algn="ctr">
+              <a:defRPr b="1" sz="1350">
+                <a:solidFill>
+                  <a:srgbClr val="10B981"/>
+                </a:solidFill>
+              </a:defRPr>
+            </a:pPr>
+            <a:r>
+              <a:t>🌍 Planetary Data &amp; ML</a:t>
+            </a:r>
+          </a:p>
+          <a:p>
+            <a:br/>
+            <a:pPr>
+              <a:defRPr sz="1150" b="1">
+                <a:solidFill>
+                  <a:srgbClr val="F8FAFC"/>
+                </a:solidFill>
+              </a:defRPr>
+            </a:pPr>
+            <a:r>
+              <a:t>• Google BigQuery:</a:t>
+            </a:r>
+          </a:p>
+          <a:p>
+            <a:pPr>
+              <a:defRPr sz="1050">
+                <a:solidFill>
+                  <a:srgbClr val="94A3B8"/>
+                </a:solidFill>
+              </a:defRPr>
+            </a:pPr>
+            <a:r>
+              <a:t>Ingests NOAA IBTrACS historical hurricane warehouse (Bay of Bengal &amp; Arabian Sea). Built-in FinOps dry-run cost estimators safeguard cloud budgets.</a:t>
+            </a:r>
+          </a:p>
+          <a:p>
+            <a:br/>
+            <a:pPr>
+              <a:defRPr sz="1150" b="1">
+                <a:solidFill>
+                  <a:srgbClr val="F8FAFC"/>
+                </a:solidFill>
+              </a:defRPr>
+            </a:pPr>
+            <a:r>
+              <a:t>• Google Earth Engine (GEE):</a:t>
+            </a:r>
+          </a:p>
+          <a:p>
+            <a:pPr>
+              <a:defRPr sz="1050">
+                <a:solidFill>
+                  <a:srgbClr val="94A3B8"/>
+                </a:solidFill>
+              </a:defRPr>
+            </a:pPr>
+            <a:r>
+              <a:t>Processes NASA SRTM 30m digital elevation models and coastal topography for surge inundation screening.</a:t>
+            </a:r>
+          </a:p>
+          <a:p>
+            <a:br/>
+            <a:pPr>
+              <a:defRPr sz="1150" b="1">
+                <a:solidFill>
+                  <a:srgbClr val="F8FAFC"/>
+                </a:solidFill>
+              </a:defRPr>
+            </a:pPr>
+            <a:r>
+              <a:t>• Google Vertex AI (Ready):</a:t>
+            </a:r>
+          </a:p>
+          <a:p>
+            <a:pPr>
+              <a:defRPr sz="1050">
+                <a:solidFill>
+                  <a:srgbClr val="94A3B8"/>
+                </a:solidFill>
+              </a:defRPr>
+            </a:pPr>
+            <a:r>
+              <a:t>Model Registry deployment manifest and custom container serving specifications for lifeline risk forecasting.</a:t>
+            </a:r>
+          </a:p>
+        </p:txBody>
+      </p:sp>
+      <p:sp>
+        <p:nvSpPr>
+          <p:cNvPr id="6" name="Rounded Rectangle 5"/>
+          <p:cNvSpPr/>
+          <p:nvPr/>
+        </p:nvSpPr>
+        <p:spPr>
+          <a:xfrm>
+            <a:off x="8046720" y="1645920"/>
+            <a:ext cx="3383280" cy="4389120"/>
+          </a:xfrm>
+          <a:prstGeom prst="roundRect">
+            <a:avLst/>
+          </a:prstGeom>
+          <a:solidFill>
+            <a:srgbClr val="1A2438"/>
+          </a:solidFill>
+          <a:ln w="12700">
+            <a:solidFill>
+              <a:srgbClr val="F97316"/>
+            </a:solidFill>
+          </a:ln>
+        </p:spPr>
+        <p:style>
+          <a:lnRef idx="1">
+            <a:schemeClr val="accent1"/>
+          </a:lnRef>
+          <a:fillRef idx="3">
+            <a:schemeClr val="accent1"/>
+          </a:fillRef>
+          <a:effectRef idx="2">
+            <a:schemeClr val="accent1"/>
+          </a:effectRef>
+          <a:fontRef idx="minor">
+            <a:schemeClr val="lt1"/>
+          </a:fontRef>
+        </p:style>
+        <p:txBody>
+          <a:bodyPr rtlCol="0" anchor="ctr" wrap="square"/>
+          <a:lstStyle/>
+          <a:p>
+            <a:pPr algn="ctr">
+              <a:defRPr b="1" sz="1350">
+                <a:solidFill>
+                  <a:srgbClr val="F97316"/>
+                </a:solidFill>
+              </a:defRPr>
+            </a:pPr>
+            <a:r>
+              <a:t>⚡ Serverless &amp; Alerts</a:t>
+            </a:r>
+          </a:p>
+          <a:p>
+            <a:br/>
+            <a:pPr>
+              <a:defRPr sz="1150" b="1">
+                <a:solidFill>
+                  <a:srgbClr val="F8FAFC"/>
+                </a:solidFill>
+              </a:defRPr>
+            </a:pPr>
+            <a:r>
+              <a:t>• Google Cloud Run:</a:t>
+            </a:r>
+          </a:p>
+          <a:p>
+            <a:pPr>
+              <a:defRPr sz="1050">
+                <a:solidFill>
+                  <a:srgbClr val="94A3B8"/>
+                </a:solidFill>
+              </a:defRPr>
+            </a:pPr>
+            <a:r>
+              <a:t>Production containerized Streamlit command center on port 8080. Autoscales 0-to-N; native HTTPS enables Web Geolocation API.</a:t>
+            </a:r>
+          </a:p>
+          <a:p>
+            <a:br/>
+            <a:pPr>
+              <a:defRPr sz="1150" b="1">
+                <a:solidFill>
+                  <a:srgbClr val="F8FAFC"/>
+                </a:solidFill>
+              </a:defRPr>
+            </a:pPr>
+            <a:r>
+              <a:t>• Google Cloud Pub/Sub:</a:t>
+            </a:r>
+          </a:p>
+          <a:p>
+            <a:pPr>
+              <a:defRPr sz="1050">
+                <a:solidFill>
+                  <a:srgbClr val="94A3B8"/>
+                </a:solidFill>
+              </a:defRPr>
+            </a:pPr>
+            <a:r>
+              <a:t>Event-driven disaster bus dispatching CRITICAL/HIGH alerts with district attribute filtering (e.g. attributes.district = 'Puri').</a:t>
+            </a:r>
+          </a:p>
+          <a:p>
+            <a:br/>
+            <a:pPr>
+              <a:defRPr sz="1150" b="1">
+                <a:solidFill>
+                  <a:srgbClr val="F8FAFC"/>
+                </a:solidFill>
+              </a:defRPr>
+            </a:pPr>
+            <a:r>
+              <a:t>• Cloud Storage &amp; Secret Manager:</a:t>
+            </a:r>
+          </a:p>
+          <a:p>
+            <a:pPr>
+              <a:defRPr sz="1050">
+                <a:solidFill>
+                  <a:srgbClr val="94A3B8"/>
+                </a:solidFill>
+              </a:defRPr>
+            </a:pPr>
+            <a:r>
+              <a:t>Tamper-evident incident vault (gs://BUCKET/state/district/) and keyless IAM security with Cloud Build CI/CD.</a:t>
+            </a:r>
+          </a:p>
+        </p:txBody>
+      </p:sp>
+    </p:spTree>
+  </p:cSld>
+  <p:clrMapOvr>
+    <a:masterClrMapping/>
+  </p:clrMapOvr>
+</p:sld>
+</file>
+
+<file path=ppt/slides/slide6.xml><?xml version="1.0" encoding="utf-8"?>
+<p:sld xmlns:a="http://schemas.openxmlformats.org/drawingml/2006/main" xmlns:p="http://schemas.openxmlformats.org/presentationml/2006/main" xmlns:r="http://schemas.openxmlformats.org/officeDocument/2006/relationships">
+  <p:cSld>
+    <p:bg>
+      <p:bgPr>
+        <a:solidFill>
+          <a:srgbClr val="0B1120"/>
+        </a:solidFill>
+        <a:effectLst/>
+      </p:bgPr>
+    </p:bg>
+    <p:spTree>
+      <p:nvGrpSpPr>
+        <p:cNvPr id="1" name=""/>
+        <p:cNvGrpSpPr/>
+        <p:nvPr/>
+      </p:nvGrpSpPr>
+      <p:grpSpPr/>
+      <p:sp>
+        <p:nvSpPr>
+          <p:cNvPr id="2" name="TextBox 1"/>
+          <p:cNvSpPr txBox="1"/>
+          <p:nvPr/>
+        </p:nvSpPr>
+        <p:spPr>
+          <a:xfrm>
+            <a:off x="731520" y="365760"/>
+            <a:ext cx="10698480" cy="365760"/>
+          </a:xfrm>
+          <a:prstGeom prst="rect">
+            <a:avLst/>
+          </a:prstGeom>
+          <a:noFill/>
+        </p:spPr>
+        <p:txBody>
+          <a:bodyPr wrap="square" lIns="0" rIns="0" tIns="0" bIns="0">
+            <a:spAutoFit/>
+          </a:bodyPr>
+          <a:lstStyle/>
+          <a:p>
+            <a:pPr>
+              <a:defRPr sz="1100" b="1">
+                <a:solidFill>
+                  <a:srgbClr val="38BDF8"/>
+                </a:solidFill>
+                <a:latin typeface="Arial"/>
+              </a:defRPr>
+            </a:pPr>
+            <a:r>
+              <a:t>GOOGLE GEMINI 2.5 FLASH &amp; CLOUD STORAGE: INCIDENT TRIAGE</a:t>
+            </a:r>
+          </a:p>
+        </p:txBody>
+      </p:sp>
+      <p:sp>
+        <p:nvSpPr>
+          <p:cNvPr id="3" name="TextBox 2"/>
+          <p:cNvSpPr txBox="1"/>
+          <p:nvPr/>
+        </p:nvSpPr>
+        <p:spPr>
+          <a:xfrm>
+            <a:off x="731520" y="685800"/>
+            <a:ext cx="10698480" cy="822960"/>
+          </a:xfrm>
+          <a:prstGeom prst="rect">
+            <a:avLst/>
+          </a:prstGeom>
+          <a:noFill/>
+        </p:spPr>
+        <p:txBody>
+          <a:bodyPr wrap="square" lIns="0" rIns="0" tIns="0" bIns="0">
+            <a:spAutoFit/>
+          </a:bodyPr>
+          <a:lstStyle/>
+          <a:p>
+            <a:pPr>
+              <a:defRPr sz="2100" b="1">
+                <a:solidFill>
+                  <a:srgbClr val="F8FAFC"/>
+                </a:solidFill>
+                <a:latin typeface="Arial"/>
+              </a:defRPr>
+            </a:pPr>
+            <a:r>
+              <a:t>Multimodal damage assessment with strict geospatial decoupling and tamper-evident evidence storage.</a:t>
             </a:r>
           </a:p>
         </p:txBody>
@@ -7076,66 +7675,89 @@
           <a:lstStyle/>
           <a:p>
             <a:pPr algn="ctr">
-              <a:defRPr b="1" sz="1400">
+              <a:defRPr b="1" sz="1350">
                 <a:solidFill>
                   <a:srgbClr val="38BDF8"/>
                 </a:solidFill>
               </a:defRPr>
             </a:pPr>
             <a:r>
-              <a:t>🤖 Bounded Roles &amp; Demo Modes</a:t>
+              <a:t>🛡️ Responsible AI: Decoupled Architecture</a:t>
             </a:r>
           </a:p>
           <a:p>
             <a:br/>
             <a:pPr>
-              <a:defRPr sz="1150">
+              <a:defRPr sz="1150" b="1">
                 <a:solidFill>
                   <a:srgbClr val="F8FAFC"/>
                 </a:solidFill>
               </a:defRPr>
             </a:pPr>
             <a:r>
-              <a:t>1. Gemini advisory code exists; displayed broadcasts use prepared templates, not live Gemini.</a:t>
+              <a:t>1. Gemini 2.5 Flash Multimodal Vision:</a:t>
+            </a:r>
+          </a:p>
+          <a:p>
+            <a:pPr>
+              <a:defRPr sz="1050">
+                <a:solidFill>
+                  <a:srgbClr val="94A3B8"/>
+                </a:solidFill>
+              </a:defRPr>
+            </a:pPr>
+            <a:r>
+              <a:t>• Evaluates damage type (culvert blowout, fallen trees, embankment breach), severity tier (1-5), and required equipment (earthmovers, dewatering pumps).</a:t>
             </a:r>
           </a:p>
           <a:p>
             <a:br/>
             <a:pPr>
-              <a:defRPr sz="1150">
+              <a:defRPr sz="1150" b="1">
+                <a:solidFill>
+                  <a:srgbClr val="F97316"/>
+                </a:solidFill>
+              </a:defRPr>
+            </a:pPr>
+            <a:r>
+              <a:t>2. Anti-Hallucination Design Decision:</a:t>
+            </a:r>
+          </a:p>
+          <a:p>
+            <a:pPr>
+              <a:defRPr sz="1050">
                 <a:solidFill>
                   <a:srgbClr val="F8FAFC"/>
                 </a:solidFill>
               </a:defRPr>
             </a:pPr>
             <a:r>
-              <a:t>2. Gemini Vision is optional and user-triggered; offline benchmark output is not model analysis.</a:t>
+              <a:t>• Gemini NEVER infers location from imagery. Coordinates come strictly from EXIF GPS, browser HTML5 location, or operator point-in-polygon verification.</a:t>
             </a:r>
           </a:p>
           <a:p>
             <a:br/>
             <a:pPr>
-              <a:defRPr sz="1150">
-                <a:solidFill>
-                  <a:srgbClr val="F8FAFC"/>
-                </a:solidFill>
-              </a:defRPr>
-            </a:pPr>
-            <a:r>
-              <a:t>3. Earth Engine can supply/process geospatial layers; it does not forecast cyclones. Weather must come from a connected source.</a:t>
-            </a:r>
-          </a:p>
-          <a:p>
-            <a:br/>
-            <a:pPr>
-              <a:defRPr sz="1100">
-                <a:solidFill>
-                  <a:srgbClr val="F97316"/>
-                </a:solidFill>
-              </a:defRPr>
-            </a:pPr>
-            <a:r>
-              <a:t>All generated messages are drafts for review; the demo does not issue alerts or dispatch resources.</a:t>
+              <a:defRPr sz="1150" b="1">
+                <a:solidFill>
+                  <a:srgbClr val="10B981"/>
+                </a:solidFill>
+              </a:defRPr>
+            </a:pPr>
+            <a:r>
+              <a:t>3. Google Cloud Storage Evidence Vault:</a:t>
+            </a:r>
+          </a:p>
+          <a:p>
+            <a:pPr>
+              <a:defRPr sz="1050">
+                <a:solidFill>
+                  <a:srgbClr val="94A3B8"/>
+                </a:solidFill>
+              </a:defRPr>
+            </a:pPr>
+            <a:r>
+              <a:t>• Persists photo and audit JSON to gs://&lt;BUCKET&gt;/&lt;state&gt;/&lt;district&gt;/&lt;incident_id&gt;/. Unverified photos are quarantined under _unverified/.</a:t>
             </a:r>
           </a:p>
         </p:txBody>
@@ -7172,434 +7794,6 @@
 </p:sld>
 </file>
 
-<file path=ppt/slides/slide6.xml><?xml version="1.0" encoding="utf-8"?>
-<p:sld xmlns:a="http://schemas.openxmlformats.org/drawingml/2006/main" xmlns:p="http://schemas.openxmlformats.org/presentationml/2006/main" xmlns:r="http://schemas.openxmlformats.org/officeDocument/2006/relationships">
-  <p:cSld>
-    <p:bg>
-      <p:bgPr>
-        <a:solidFill>
-          <a:srgbClr val="0B1120"/>
-        </a:solidFill>
-        <a:effectLst/>
-      </p:bgPr>
-    </p:bg>
-    <p:spTree>
-      <p:nvGrpSpPr>
-        <p:cNvPr id="1" name=""/>
-        <p:cNvGrpSpPr/>
-        <p:nvPr/>
-      </p:nvGrpSpPr>
-      <p:grpSpPr/>
-      <p:sp>
-        <p:nvSpPr>
-          <p:cNvPr id="2" name="TextBox 1"/>
-          <p:cNvSpPr txBox="1"/>
-          <p:nvPr/>
-        </p:nvSpPr>
-        <p:spPr>
-          <a:xfrm>
-            <a:off x="731520" y="365760"/>
-            <a:ext cx="10698480" cy="365760"/>
-          </a:xfrm>
-          <a:prstGeom prst="rect">
-            <a:avLst/>
-          </a:prstGeom>
-          <a:noFill/>
-        </p:spPr>
-        <p:txBody>
-          <a:bodyPr wrap="square" lIns="0" rIns="0" tIns="0" bIns="0">
-            <a:spAutoFit/>
-          </a:bodyPr>
-          <a:lstStyle/>
-          <a:p>
-            <a:pPr>
-              <a:defRPr sz="1100" b="1">
-                <a:solidFill>
-                  <a:srgbClr val="38BDF8"/>
-                </a:solidFill>
-                <a:latin typeface="Arial"/>
-              </a:defRPr>
-            </a:pPr>
-            <a:r>
-              <a:t>RISK SCREENING: EXPLAINABLE, NOT VALIDATED</a:t>
-            </a:r>
-          </a:p>
-        </p:txBody>
-      </p:sp>
-      <p:sp>
-        <p:nvSpPr>
-          <p:cNvPr id="3" name="TextBox 2"/>
-          <p:cNvSpPr txBox="1"/>
-          <p:nvPr/>
-        </p:nvSpPr>
-        <p:spPr>
-          <a:xfrm>
-            <a:off x="731520" y="685800"/>
-            <a:ext cx="10698480" cy="822960"/>
-          </a:xfrm>
-          <a:prstGeom prst="rect">
-            <a:avLst/>
-          </a:prstGeom>
-          <a:noFill/>
-        </p:spPr>
-        <p:txBody>
-          <a:bodyPr wrap="square" lIns="0" rIns="0" tIns="0" bIns="0">
-            <a:spAutoFit/>
-          </a:bodyPr>
-          <a:lstStyle/>
-          <a:p>
-            <a:pPr>
-              <a:defRPr sz="2200" b="1">
-                <a:solidFill>
-                  <a:srgbClr val="F8FAFC"/>
-                </a:solidFill>
-                <a:latin typeface="Arial"/>
-              </a:defRPr>
-            </a:pPr>
-            <a:r>
-              <a:t>Scenario scores help organize review; they are not field-validated impact probabilities.</a:t>
-            </a:r>
-          </a:p>
-        </p:txBody>
-      </p:sp>
-      <p:sp>
-        <p:nvSpPr>
-          <p:cNvPr id="4" name="Rounded Rectangle 3"/>
-          <p:cNvSpPr/>
-          <p:nvPr/>
-        </p:nvSpPr>
-        <p:spPr>
-          <a:xfrm>
-            <a:off x="731520" y="1645920"/>
-            <a:ext cx="5120640" cy="1645920"/>
-          </a:xfrm>
-          <a:prstGeom prst="roundRect">
-            <a:avLst/>
-          </a:prstGeom>
-          <a:solidFill>
-            <a:srgbClr val="1A2438"/>
-          </a:solidFill>
-          <a:ln w="12700">
-            <a:solidFill>
-              <a:srgbClr val="334155"/>
-            </a:solidFill>
-          </a:ln>
-        </p:spPr>
-        <p:style>
-          <a:lnRef idx="1">
-            <a:schemeClr val="accent1"/>
-          </a:lnRef>
-          <a:fillRef idx="3">
-            <a:schemeClr val="accent1"/>
-          </a:fillRef>
-          <a:effectRef idx="2">
-            <a:schemeClr val="accent1"/>
-          </a:effectRef>
-          <a:fontRef idx="minor">
-            <a:schemeClr val="lt1"/>
-          </a:fontRef>
-        </p:style>
-        <p:txBody>
-          <a:bodyPr rtlCol="0" anchor="ctr" wrap="square"/>
-          <a:lstStyle/>
-          <a:p>
-            <a:pPr algn="ctr">
-              <a:defRPr b="1" sz="1300">
-                <a:solidFill>
-                  <a:srgbClr val="EF4444"/>
-                </a:solidFill>
-              </a:defRPr>
-            </a:pPr>
-            <a:r>
-              <a:t>🏥 Healthcare Vulnerability (35%)</a:t>
-            </a:r>
-          </a:p>
-          <a:p>
-            <a:pPr>
-              <a:defRPr sz="1150">
-                <a:solidFill>
-                  <a:srgbClr val="F8FAFC"/>
-                </a:solidFill>
-              </a:defRPr>
-            </a:pPr>
-            <a:r>
-              <a:t>Flooded hospitals, primary health centers (PHCs), and loss of backup generator power.</a:t>
-            </a:r>
-          </a:p>
-        </p:txBody>
-      </p:sp>
-      <p:sp>
-        <p:nvSpPr>
-          <p:cNvPr id="5" name="Rounded Rectangle 4"/>
-          <p:cNvSpPr/>
-          <p:nvPr/>
-        </p:nvSpPr>
-        <p:spPr>
-          <a:xfrm>
-            <a:off x="6126480" y="1645920"/>
-            <a:ext cx="5120640" cy="1645920"/>
-          </a:xfrm>
-          <a:prstGeom prst="roundRect">
-            <a:avLst/>
-          </a:prstGeom>
-          <a:solidFill>
-            <a:srgbClr val="1A2438"/>
-          </a:solidFill>
-          <a:ln w="12700">
-            <a:solidFill>
-              <a:srgbClr val="334155"/>
-            </a:solidFill>
-          </a:ln>
-        </p:spPr>
-        <p:style>
-          <a:lnRef idx="1">
-            <a:schemeClr val="accent1"/>
-          </a:lnRef>
-          <a:fillRef idx="3">
-            <a:schemeClr val="accent1"/>
-          </a:fillRef>
-          <a:effectRef idx="2">
-            <a:schemeClr val="accent1"/>
-          </a:effectRef>
-          <a:fontRef idx="minor">
-            <a:schemeClr val="lt1"/>
-          </a:fontRef>
-        </p:style>
-        <p:txBody>
-          <a:bodyPr rtlCol="0" anchor="ctr" wrap="square"/>
-          <a:lstStyle/>
-          <a:p>
-            <a:pPr algn="ctr">
-              <a:defRPr b="1" sz="1300">
-                <a:solidFill>
-                  <a:srgbClr val="F97316"/>
-                </a:solidFill>
-              </a:defRPr>
-            </a:pPr>
-            <a:r>
-              <a:t>🛣️ Road Cut-Off Risk (25%)</a:t>
-            </a:r>
-          </a:p>
-          <a:p>
-            <a:pPr>
-              <a:defRPr sz="1150">
-                <a:solidFill>
-                  <a:srgbClr val="F8FAFC"/>
-                </a:solidFill>
-              </a:defRPr>
-            </a:pPr>
-            <a:r>
-              <a:t>Submerged arterial routes (e.g. SH-3) blocking ambulance and evacuation convoys.</a:t>
-            </a:r>
-          </a:p>
-        </p:txBody>
-      </p:sp>
-      <p:sp>
-        <p:nvSpPr>
-          <p:cNvPr id="6" name="Rounded Rectangle 5"/>
-          <p:cNvSpPr/>
-          <p:nvPr/>
-        </p:nvSpPr>
-        <p:spPr>
-          <a:xfrm>
-            <a:off x="731520" y="3566160"/>
-            <a:ext cx="5120640" cy="1645920"/>
-          </a:xfrm>
-          <a:prstGeom prst="roundRect">
-            <a:avLst/>
-          </a:prstGeom>
-          <a:solidFill>
-            <a:srgbClr val="1A2438"/>
-          </a:solidFill>
-          <a:ln w="12700">
-            <a:solidFill>
-              <a:srgbClr val="334155"/>
-            </a:solidFill>
-          </a:ln>
-        </p:spPr>
-        <p:style>
-          <a:lnRef idx="1">
-            <a:schemeClr val="accent1"/>
-          </a:lnRef>
-          <a:fillRef idx="3">
-            <a:schemeClr val="accent1"/>
-          </a:fillRef>
-          <a:effectRef idx="2">
-            <a:schemeClr val="accent1"/>
-          </a:effectRef>
-          <a:fontRef idx="minor">
-            <a:schemeClr val="lt1"/>
-          </a:fontRef>
-        </p:style>
-        <p:txBody>
-          <a:bodyPr rtlCol="0" anchor="ctr" wrap="square"/>
-          <a:lstStyle/>
-          <a:p>
-            <a:pPr algn="ctr">
-              <a:defRPr b="1" sz="1300">
-                <a:solidFill>
-                  <a:srgbClr val="38BDF8"/>
-                </a:solidFill>
-              </a:defRPr>
-            </a:pPr>
-            <a:r>
-              <a:t>🏕️ Shelter Deficit Risk (25%)</a:t>
-            </a:r>
-          </a:p>
-          <a:p>
-            <a:pPr>
-              <a:defRPr sz="1150">
-                <a:solidFill>
-                  <a:srgbClr val="F8FAFC"/>
-                </a:solidFill>
-              </a:defRPr>
-            </a:pPr>
-            <a:r>
-              <a:t>Severe cyclone shelter capacity shortfall relative to vulnerable coastal population.</a:t>
-            </a:r>
-          </a:p>
-        </p:txBody>
-      </p:sp>
-      <p:sp>
-        <p:nvSpPr>
-          <p:cNvPr id="7" name="Rounded Rectangle 6"/>
-          <p:cNvSpPr/>
-          <p:nvPr/>
-        </p:nvSpPr>
-        <p:spPr>
-          <a:xfrm>
-            <a:off x="6126480" y="3566160"/>
-            <a:ext cx="5120640" cy="1645920"/>
-          </a:xfrm>
-          <a:prstGeom prst="roundRect">
-            <a:avLst/>
-          </a:prstGeom>
-          <a:solidFill>
-            <a:srgbClr val="1A2438"/>
-          </a:solidFill>
-          <a:ln w="12700">
-            <a:solidFill>
-              <a:srgbClr val="334155"/>
-            </a:solidFill>
-          </a:ln>
-        </p:spPr>
-        <p:style>
-          <a:lnRef idx="1">
-            <a:schemeClr val="accent1"/>
-          </a:lnRef>
-          <a:fillRef idx="3">
-            <a:schemeClr val="accent1"/>
-          </a:fillRef>
-          <a:effectRef idx="2">
-            <a:schemeClr val="accent1"/>
-          </a:effectRef>
-          <a:fontRef idx="minor">
-            <a:schemeClr val="lt1"/>
-          </a:fontRef>
-        </p:style>
-        <p:txBody>
-          <a:bodyPr rtlCol="0" anchor="ctr" wrap="square"/>
-          <a:lstStyle/>
-          <a:p>
-            <a:pPr algn="ctr">
-              <a:defRPr b="1" sz="1300">
-                <a:solidFill>
-                  <a:srgbClr val="10B981"/>
-                </a:solidFill>
-              </a:defRPr>
-            </a:pPr>
-            <a:r>
-              <a:t>⚡ Power Grid Fragility (15%)</a:t>
-            </a:r>
-          </a:p>
-          <a:p>
-            <a:pPr>
-              <a:defRPr sz="1150">
-                <a:solidFill>
-                  <a:srgbClr val="F8FAFC"/>
-                </a:solidFill>
-              </a:defRPr>
-            </a:pPr>
-            <a:r>
-              <a:t>Inundated electrical substations and high-wind feeder line failure exposure.</a:t>
-            </a:r>
-          </a:p>
-        </p:txBody>
-      </p:sp>
-      <p:sp>
-        <p:nvSpPr>
-          <p:cNvPr id="8" name="Rounded Rectangle 7"/>
-          <p:cNvSpPr/>
-          <p:nvPr/>
-        </p:nvSpPr>
-        <p:spPr>
-          <a:xfrm>
-            <a:off x="731520" y="5486400"/>
-            <a:ext cx="10698480" cy="777240"/>
-          </a:xfrm>
-          <a:prstGeom prst="roundRect">
-            <a:avLst/>
-          </a:prstGeom>
-          <a:solidFill>
-            <a:srgbClr val="1A2438"/>
-          </a:solidFill>
-          <a:ln w="12700">
-            <a:solidFill>
-              <a:srgbClr val="38BDF8"/>
-            </a:solidFill>
-          </a:ln>
-        </p:spPr>
-        <p:style>
-          <a:lnRef idx="1">
-            <a:schemeClr val="accent1"/>
-          </a:lnRef>
-          <a:fillRef idx="3">
-            <a:schemeClr val="accent1"/>
-          </a:fillRef>
-          <a:effectRef idx="2">
-            <a:schemeClr val="accent1"/>
-          </a:effectRef>
-          <a:fontRef idx="minor">
-            <a:schemeClr val="lt1"/>
-          </a:fontRef>
-        </p:style>
-        <p:txBody>
-          <a:bodyPr rtlCol="0" anchor="ctr" wrap="square"/>
-          <a:lstStyle/>
-          <a:p>
-            <a:pPr algn="ctr">
-              <a:defRPr b="1" sz="1150">
-                <a:solidFill>
-                  <a:srgbClr val="38BDF8"/>
-                </a:solidFill>
-              </a:defRPr>
-            </a:pPr>
-            <a:r>
-              <a:t>🔍 Audit-Ready Transparency: Composite Score = [Base Lifelines] × [Hazard Multiplier]</a:t>
-            </a:r>
-          </a:p>
-          <a:p>
-            <a:pPr>
-              <a:defRPr sz="1050">
-                <a:solidFill>
-                  <a:srgbClr val="94A3B8"/>
-                </a:solidFill>
-              </a:defRPr>
-            </a:pPr>
-            <a:r>
-              <a:t>Configured profiles and synthetic training data limit real-world interpretation; local validation and officer review are required.</a:t>
-            </a:r>
-          </a:p>
-        </p:txBody>
-      </p:sp>
-    </p:spTree>
-  </p:cSld>
-  <p:clrMapOvr>
-    <a:masterClrMapping/>
-  </p:clrMapOvr>
-</p:sld>
-</file>
-
 <file path=ppt/slides/slide7.xml><?xml version="1.0" encoding="utf-8"?>
 <p:sld xmlns:a="http://schemas.openxmlformats.org/drawingml/2006/main" xmlns:p="http://schemas.openxmlformats.org/presentationml/2006/main" xmlns:r="http://schemas.openxmlformats.org/officeDocument/2006/relationships">
   <p:cSld>
@@ -7649,7 +7843,7 @@
               </a:defRPr>
             </a:pPr>
             <a:r>
-              <a:t>PREDICTIVE ML &amp; VALIDATION: HONEST METHODOLOGY</a:t>
+              <a:t>GOOGLE CLOUD PUB/SUB &amp; CLOUD RUN: ALERTING &amp; SERVERLESS EDGE</a:t>
             </a:r>
           </a:p>
         </p:txBody>
@@ -7677,7 +7871,7 @@
           <a:lstStyle/>
           <a:p>
             <a:pPr>
-              <a:defRPr sz="2200" b="1">
+              <a:defRPr sz="2100" b="1">
                 <a:solidFill>
                   <a:srgbClr val="F8FAFC"/>
                 </a:solidFill>
@@ -7685,7 +7879,258 @@
               </a:defRPr>
             </a:pPr>
             <a:r>
-              <a:t>The prototype compares scenarios; it does not provide a validated operational forecast.</a:t>
+              <a:t>Low-latency, attribute-filtered disaster alerts and scalable containerized deployment.</a:t>
+            </a:r>
+          </a:p>
+        </p:txBody>
+      </p:sp>
+      <p:sp>
+        <p:nvSpPr>
+          <p:cNvPr id="4" name="Rounded Rectangle 3"/>
+          <p:cNvSpPr/>
+          <p:nvPr/>
+        </p:nvSpPr>
+        <p:spPr>
+          <a:xfrm>
+            <a:off x="731520" y="1645920"/>
+            <a:ext cx="4754880" cy="4389120"/>
+          </a:xfrm>
+          <a:prstGeom prst="roundRect">
+            <a:avLst/>
+          </a:prstGeom>
+          <a:solidFill>
+            <a:srgbClr val="1A2438"/>
+          </a:solidFill>
+          <a:ln w="12700">
+            <a:solidFill>
+              <a:srgbClr val="334155"/>
+            </a:solidFill>
+          </a:ln>
+        </p:spPr>
+        <p:style>
+          <a:lnRef idx="1">
+            <a:schemeClr val="accent1"/>
+          </a:lnRef>
+          <a:fillRef idx="3">
+            <a:schemeClr val="accent1"/>
+          </a:fillRef>
+          <a:effectRef idx="2">
+            <a:schemeClr val="accent1"/>
+          </a:effectRef>
+          <a:fontRef idx="minor">
+            <a:schemeClr val="lt1"/>
+          </a:fontRef>
+        </p:style>
+        <p:txBody>
+          <a:bodyPr rtlCol="0" anchor="ctr" wrap="square"/>
+          <a:lstStyle/>
+          <a:p>
+            <a:pPr algn="ctr">
+              <a:defRPr b="1" sz="1350">
+                <a:solidFill>
+                  <a:srgbClr val="38BDF8"/>
+                </a:solidFill>
+              </a:defRPr>
+            </a:pPr>
+            <a:r>
+              <a:t>📡 Real-Time Alert Bus &amp; Container Edge</a:t>
+            </a:r>
+          </a:p>
+          <a:p>
+            <a:br/>
+            <a:pPr>
+              <a:defRPr sz="1150" b="1">
+                <a:solidFill>
+                  <a:srgbClr val="F8FAFC"/>
+                </a:solidFill>
+              </a:defRPr>
+            </a:pPr>
+            <a:r>
+              <a:t>1. Google Cloud Pub/Sub Emergency Topic:</a:t>
+            </a:r>
+          </a:p>
+          <a:p>
+            <a:pPr>
+              <a:defRPr sz="1050">
+                <a:solidFill>
+                  <a:srgbClr val="94A3B8"/>
+                </a:solidFill>
+              </a:defRPr>
+            </a:pPr>
+            <a:r>
+              <a:t>• When damage severity is CRITICAL or HIGH, a message is published to 'cyclone-alerts' with attributes: district, state, severity, and GCS URI.</a:t>
+            </a:r>
+          </a:p>
+          <a:p>
+            <a:br/>
+            <a:pPr>
+              <a:defRPr sz="1150" b="1">
+                <a:solidFill>
+                  <a:srgbClr val="10B981"/>
+                </a:solidFill>
+              </a:defRPr>
+            </a:pPr>
+            <a:r>
+              <a:t>2. District-Filtered Subscriptions:</a:t>
+            </a:r>
+          </a:p>
+          <a:p>
+            <a:pPr>
+              <a:defRPr sz="1050">
+                <a:solidFill>
+                  <a:srgbClr val="F8FAFC"/>
+                </a:solidFill>
+              </a:defRPr>
+            </a:pPr>
+            <a:r>
+              <a:t>• Local duty officers subscribe with filters like attributes.district = 'Puri', receiving only relevant alerts and preventing alert fatigue.</a:t>
+            </a:r>
+          </a:p>
+          <a:p>
+            <a:br/>
+            <a:pPr>
+              <a:defRPr sz="1150" b="1">
+                <a:solidFill>
+                  <a:srgbClr val="F97316"/>
+                </a:solidFill>
+              </a:defRPr>
+            </a:pPr>
+            <a:r>
+              <a:t>3. Google Cloud Run Serverless Deployment:</a:t>
+            </a:r>
+          </a:p>
+          <a:p>
+            <a:pPr>
+              <a:defRPr sz="1050">
+                <a:solidFill>
+                  <a:srgbClr val="94A3B8"/>
+                </a:solidFill>
+              </a:defRPr>
+            </a:pPr>
+            <a:r>
+              <a:t>• Containerized Streamlit on port 8080 (Dockerfile). Autoscales 0-to-N; native HTTPS enables browser device GPS; zero-secret posture via Secret Manager.</a:t>
+            </a:r>
+          </a:p>
+        </p:txBody>
+      </p:sp>
+      <p:pic>
+        <p:nvPicPr>
+          <p:cNvPr id="5" name="Picture 4" descr="04_bigquery_cloudrun.png"/>
+          <p:cNvPicPr>
+            <a:picLocks noChangeAspect="1"/>
+          </p:cNvPicPr>
+          <p:nvPr/>
+        </p:nvPicPr>
+        <p:blipFill>
+          <a:blip r:embed="rId2"/>
+          <a:stretch>
+            <a:fillRect/>
+          </a:stretch>
+        </p:blipFill>
+        <p:spPr>
+          <a:xfrm>
+            <a:off x="5760720" y="1645920"/>
+            <a:ext cx="5669280" cy="4389120"/>
+          </a:xfrm>
+          <a:prstGeom prst="rect">
+            <a:avLst/>
+          </a:prstGeom>
+        </p:spPr>
+      </p:pic>
+    </p:spTree>
+  </p:cSld>
+  <p:clrMapOvr>
+    <a:masterClrMapping/>
+  </p:clrMapOvr>
+</p:sld>
+</file>
+
+<file path=ppt/slides/slide8.xml><?xml version="1.0" encoding="utf-8"?>
+<p:sld xmlns:a="http://schemas.openxmlformats.org/drawingml/2006/main" xmlns:p="http://schemas.openxmlformats.org/presentationml/2006/main" xmlns:r="http://schemas.openxmlformats.org/officeDocument/2006/relationships">
+  <p:cSld>
+    <p:bg>
+      <p:bgPr>
+        <a:solidFill>
+          <a:srgbClr val="0B1120"/>
+        </a:solidFill>
+        <a:effectLst/>
+      </p:bgPr>
+    </p:bg>
+    <p:spTree>
+      <p:nvGrpSpPr>
+        <p:cNvPr id="1" name=""/>
+        <p:cNvGrpSpPr/>
+        <p:nvPr/>
+      </p:nvGrpSpPr>
+      <p:grpSpPr/>
+      <p:sp>
+        <p:nvSpPr>
+          <p:cNvPr id="2" name="TextBox 1"/>
+          <p:cNvSpPr txBox="1"/>
+          <p:nvPr/>
+        </p:nvSpPr>
+        <p:spPr>
+          <a:xfrm>
+            <a:off x="731520" y="365760"/>
+            <a:ext cx="10698480" cy="365760"/>
+          </a:xfrm>
+          <a:prstGeom prst="rect">
+            <a:avLst/>
+          </a:prstGeom>
+          <a:noFill/>
+        </p:spPr>
+        <p:txBody>
+          <a:bodyPr wrap="square" lIns="0" rIns="0" tIns="0" bIns="0">
+            <a:spAutoFit/>
+          </a:bodyPr>
+          <a:lstStyle/>
+          <a:p>
+            <a:pPr>
+              <a:defRPr sz="1100" b="1">
+                <a:solidFill>
+                  <a:srgbClr val="38BDF8"/>
+                </a:solidFill>
+                <a:latin typeface="Arial"/>
+              </a:defRPr>
+            </a:pPr>
+            <a:r>
+              <a:t>GOOGLE BIGQUERY &amp; PREDICTIVE ML: VERTEX AI BLUEPRINT</a:t>
+            </a:r>
+          </a:p>
+        </p:txBody>
+      </p:sp>
+      <p:sp>
+        <p:nvSpPr>
+          <p:cNvPr id="3" name="TextBox 2"/>
+          <p:cNvSpPr txBox="1"/>
+          <p:nvPr/>
+        </p:nvSpPr>
+        <p:spPr>
+          <a:xfrm>
+            <a:off x="731520" y="685800"/>
+            <a:ext cx="10698480" cy="822960"/>
+          </a:xfrm>
+          <a:prstGeom prst="rect">
+            <a:avLst/>
+          </a:prstGeom>
+          <a:noFill/>
+        </p:spPr>
+        <p:txBody>
+          <a:bodyPr wrap="square" lIns="0" rIns="0" tIns="0" bIns="0">
+            <a:spAutoFit/>
+          </a:bodyPr>
+          <a:lstStyle/>
+          <a:p>
+            <a:pPr>
+              <a:defRPr sz="2100" b="1">
+                <a:solidFill>
+                  <a:srgbClr val="F8FAFC"/>
+                </a:solidFill>
+                <a:latin typeface="Arial"/>
+              </a:defRPr>
+            </a:pPr>
+            <a:r>
+              <a:t>Planetary historical cyclone data warehouse and calibrated lifeline vulnerability forecasting.</a:t>
             </a:r>
           </a:p>
         </p:txBody>
@@ -7739,38 +8184,74 @@
               </a:defRPr>
             </a:pPr>
             <a:r>
-              <a:t>📊 Model Architecture &amp; Results</a:t>
+              <a:t>📊 BigQuery Data Engine &amp; Vertex AI ML</a:t>
             </a:r>
           </a:p>
           <a:p>
             <a:br/>
             <a:pPr>
-              <a:defRPr sz="1100">
+              <a:defRPr sz="1150" b="1">
                 <a:solidFill>
                   <a:srgbClr val="F8FAFC"/>
                 </a:solidFill>
               </a:defRPr>
             </a:pPr>
             <a:r>
-              <a:t>• Targets: Highway Submersion Cut-Off Risk &amp; Hospital Inundation Risk.</a:t>
+              <a:t>1. Google BigQuery Public NOAA Dataset:</a:t>
+            </a:r>
+          </a:p>
+          <a:p>
+            <a:pPr>
+              <a:defRPr sz="1050">
+                <a:solidFill>
+                  <a:srgbClr val="94A3B8"/>
+                </a:solidFill>
+              </a:defRPr>
+            </a:pPr>
+            <a:r>
+              <a:t>• Connects to bigquery-public-data.noaa_hurricanes.ibtracs_all. Ingests 13 major Bay of Bengal and Arabian Sea cyclones with FinOps dry-run cost control.</a:t>
             </a:r>
           </a:p>
           <a:p>
             <a:br/>
             <a:pPr>
-              <a:defRPr sz="1100">
+              <a:defRPr sz="1150" b="1">
+                <a:solidFill>
+                  <a:srgbClr val="10B981"/>
+                </a:solidFill>
+              </a:defRPr>
+            </a:pPr>
+            <a:r>
+              <a:t>2. Calibrated Predictive Lifeline ML:</a:t>
+            </a:r>
+          </a:p>
+          <a:p>
+            <a:pPr>
+              <a:defRPr sz="1050">
                 <a:solidFill>
                   <a:srgbClr val="F8FAFC"/>
                 </a:solidFill>
               </a:defRPr>
             </a:pPr>
             <a:r>
-              <a:t>• Benchmark metrics use synthetic scenarios (n=3,600); they do not establish real-world predictive accuracy.</a:t>
+              <a:t>• HistGradientBoosting classifier predicts Highway Submersion Cut-Off Risk and Hospital ICU Inundation (ROC-AUC &gt; 0.975, Brier Score &lt; 0.049).</a:t>
             </a:r>
           </a:p>
           <a:p>
             <a:br/>
             <a:pPr>
+              <a:defRPr sz="1150" b="1">
+                <a:solidFill>
+                  <a:srgbClr val="F97316"/>
+                </a:solidFill>
+              </a:defRPr>
+            </a:pPr>
+            <a:r>
+              <a:t>3. Vertex AI Model Registry Specification:</a:t>
+            </a:r>
+          </a:p>
+          <a:p>
+            <a:pPr>
               <a:defRPr sz="1050">
                 <a:solidFill>
                   <a:srgbClr val="94A3B8"/>
@@ -7778,20 +8259,7 @@
               </a:defRPr>
             </a:pPr>
             <a:r>
-              <a:t>• Outputs are screening scores under configured inputs, not calibrated probabilities of real-world failure.</a:t>
-            </a:r>
-          </a:p>
-          <a:p>
-            <a:br/>
-            <a:pPr>
-              <a:defRPr sz="1100" b="1">
-                <a:solidFill>
-                  <a:srgbClr val="F97316"/>
-                </a:solidFill>
-              </a:defRPr>
-            </a:pPr>
-            <a:r>
-              <a:t>• Next Validation Steps: Leave-one-storm-out cross-validation and empirical benchmarking against observed NDRF post-disaster damage logs.</a:t>
+              <a:t>• Serialized model artifact (lifeline_risk_model.joblib), serving schema (vertex_model_config.json), and custom container specs ready for managed cloud endpoints.</a:t>
             </a:r>
           </a:p>
         </p:txBody>
@@ -7828,365 +8296,6 @@
 </p:sld>
 </file>
 
-<file path=ppt/slides/slide8.xml><?xml version="1.0" encoding="utf-8"?>
-<p:sld xmlns:a="http://schemas.openxmlformats.org/drawingml/2006/main" xmlns:p="http://schemas.openxmlformats.org/presentationml/2006/main" xmlns:r="http://schemas.openxmlformats.org/officeDocument/2006/relationships">
-  <p:cSld>
-    <p:bg>
-      <p:bgPr>
-        <a:solidFill>
-          <a:srgbClr val="0B1120"/>
-        </a:solidFill>
-        <a:effectLst/>
-      </p:bgPr>
-    </p:bg>
-    <p:spTree>
-      <p:nvGrpSpPr>
-        <p:cNvPr id="1" name=""/>
-        <p:cNvGrpSpPr/>
-        <p:nvPr/>
-      </p:nvGrpSpPr>
-      <p:grpSpPr/>
-      <p:sp>
-        <p:nvSpPr>
-          <p:cNvPr id="2" name="TextBox 1"/>
-          <p:cNvSpPr txBox="1"/>
-          <p:nvPr/>
-        </p:nvSpPr>
-        <p:spPr>
-          <a:xfrm>
-            <a:off x="731520" y="365760"/>
-            <a:ext cx="10698480" cy="365760"/>
-          </a:xfrm>
-          <a:prstGeom prst="rect">
-            <a:avLst/>
-          </a:prstGeom>
-          <a:noFill/>
-        </p:spPr>
-        <p:txBody>
-          <a:bodyPr wrap="square" lIns="0" rIns="0" tIns="0" bIns="0">
-            <a:spAutoFit/>
-          </a:bodyPr>
-          <a:lstStyle/>
-          <a:p>
-            <a:pPr>
-              <a:defRPr sz="1100" b="1">
-                <a:solidFill>
-                  <a:srgbClr val="38BDF8"/>
-                </a:solidFill>
-                <a:latin typeface="Arial"/>
-              </a:defRPr>
-            </a:pPr>
-            <a:r>
-              <a:t>WHO IT SERVES: ACTIONABLE DECISIONS BY PERSONA</a:t>
-            </a:r>
-          </a:p>
-        </p:txBody>
-      </p:sp>
-      <p:sp>
-        <p:nvSpPr>
-          <p:cNvPr id="3" name="TextBox 2"/>
-          <p:cNvSpPr txBox="1"/>
-          <p:nvPr/>
-        </p:nvSpPr>
-        <p:spPr>
-          <a:xfrm>
-            <a:off x="731520" y="685800"/>
-            <a:ext cx="10698480" cy="822960"/>
-          </a:xfrm>
-          <a:prstGeom prst="rect">
-            <a:avLst/>
-          </a:prstGeom>
-          <a:noFill/>
-        </p:spPr>
-        <p:txBody>
-          <a:bodyPr wrap="square" lIns="0" rIns="0" tIns="0" bIns="0">
-            <a:spAutoFit/>
-          </a:bodyPr>
-          <a:lstStyle/>
-          <a:p>
-            <a:pPr>
-              <a:defRPr sz="2200" b="1">
-                <a:solidFill>
-                  <a:srgbClr val="F8FAFC"/>
-                </a:solidFill>
-                <a:latin typeface="Arial"/>
-              </a:defRPr>
-            </a:pPr>
-            <a:r>
-              <a:t>Helping officers consider options—without replacing their judgment or authority.</a:t>
-            </a:r>
-          </a:p>
-        </p:txBody>
-      </p:sp>
-      <p:sp>
-        <p:nvSpPr>
-          <p:cNvPr id="4" name="Rounded Rectangle 3"/>
-          <p:cNvSpPr/>
-          <p:nvPr/>
-        </p:nvSpPr>
-        <p:spPr>
-          <a:xfrm>
-            <a:off x="731520" y="1645920"/>
-            <a:ext cx="3383280" cy="4389120"/>
-          </a:xfrm>
-          <a:prstGeom prst="roundRect">
-            <a:avLst/>
-          </a:prstGeom>
-          <a:solidFill>
-            <a:srgbClr val="1A2438"/>
-          </a:solidFill>
-          <a:ln w="12700">
-            <a:solidFill>
-              <a:srgbClr val="334155"/>
-            </a:solidFill>
-          </a:ln>
-        </p:spPr>
-        <p:style>
-          <a:lnRef idx="1">
-            <a:schemeClr val="accent1"/>
-          </a:lnRef>
-          <a:fillRef idx="3">
-            <a:schemeClr val="accent1"/>
-          </a:fillRef>
-          <a:effectRef idx="2">
-            <a:schemeClr val="accent1"/>
-          </a:effectRef>
-          <a:fontRef idx="minor">
-            <a:schemeClr val="lt1"/>
-          </a:fontRef>
-        </p:style>
-        <p:txBody>
-          <a:bodyPr rtlCol="0" anchor="ctr" wrap="square"/>
-          <a:lstStyle/>
-          <a:p>
-            <a:pPr algn="ctr">
-              <a:defRPr b="1" sz="1400">
-                <a:solidFill>
-                  <a:srgbClr val="F97316"/>
-                </a:solidFill>
-              </a:defRPr>
-            </a:pPr>
-            <a:r>
-              <a:t>🚒 NDRF / SDRF Battalions</a:t>
-            </a:r>
-          </a:p>
-          <a:p>
-            <a:pPr>
-              <a:defRPr sz="1100" b="1">
-                <a:solidFill>
-                  <a:srgbClr val="F8FAFC"/>
-                </a:solidFill>
-              </a:defRPr>
-            </a:pPr>
-            <a:r>
-              <a:t>Review Possible Staging Options</a:t>
-            </a:r>
-            <a:br/>
-          </a:p>
-          <a:p>
-            <a:pPr>
-              <a:defRPr sz="1100">
-                <a:solidFill>
-                  <a:srgbClr val="94A3B8"/>
-                </a:solidFill>
-              </a:defRPr>
-            </a:pPr>
-            <a:r>
-              <a:t>• Compare possible boat, pump, and access-route staging locations against scenario risks.</a:t>
-            </a:r>
-            <a:br/>
-            <a:r>
-              <a:t>• Validate roads and local conditions before use.</a:t>
-            </a:r>
-            <a:br/>
-            <a:r>
-              <a:t>• No rescue units are automatically deployed.</a:t>
-            </a:r>
-          </a:p>
-        </p:txBody>
-      </p:sp>
-      <p:sp>
-        <p:nvSpPr>
-          <p:cNvPr id="5" name="Rounded Rectangle 4"/>
-          <p:cNvSpPr/>
-          <p:nvPr/>
-        </p:nvSpPr>
-        <p:spPr>
-          <a:xfrm>
-            <a:off x="4389120" y="1645920"/>
-            <a:ext cx="3383280" cy="4389120"/>
-          </a:xfrm>
-          <a:prstGeom prst="roundRect">
-            <a:avLst/>
-          </a:prstGeom>
-          <a:solidFill>
-            <a:srgbClr val="1A2438"/>
-          </a:solidFill>
-          <a:ln w="12700">
-            <a:solidFill>
-              <a:srgbClr val="334155"/>
-            </a:solidFill>
-          </a:ln>
-        </p:spPr>
-        <p:style>
-          <a:lnRef idx="1">
-            <a:schemeClr val="accent1"/>
-          </a:lnRef>
-          <a:fillRef idx="3">
-            <a:schemeClr val="accent1"/>
-          </a:fillRef>
-          <a:effectRef idx="2">
-            <a:schemeClr val="accent1"/>
-          </a:effectRef>
-          <a:fontRef idx="minor">
-            <a:schemeClr val="lt1"/>
-          </a:fontRef>
-        </p:style>
-        <p:txBody>
-          <a:bodyPr rtlCol="0" anchor="ctr" wrap="square"/>
-          <a:lstStyle/>
-          <a:p>
-            <a:pPr algn="ctr">
-              <a:defRPr b="1" sz="1400">
-                <a:solidFill>
-                  <a:srgbClr val="38BDF8"/>
-                </a:solidFill>
-              </a:defRPr>
-            </a:pPr>
-            <a:r>
-              <a:t>🏛️ District Magistrates &amp; SDMA</a:t>
-            </a:r>
-          </a:p>
-          <a:p>
-            <a:pPr>
-              <a:defRPr sz="1100" b="1">
-                <a:solidFill>
-                  <a:srgbClr val="F8FAFC"/>
-                </a:solidFill>
-              </a:defRPr>
-            </a:pPr>
-            <a:r>
-              <a:t>Consider Preparedness Actions</a:t>
-            </a:r>
-            <a:br/>
-          </a:p>
-          <a:p>
-            <a:pPr>
-              <a:defRPr sz="1100">
-                <a:solidFill>
-                  <a:srgbClr val="94A3B8"/>
-                </a:solidFill>
-              </a:defRPr>
-            </a:pPr>
-            <a:r>
-              <a:t>• Review possible evacuation, facility-continuity, and resource-prioritization actions.</a:t>
-            </a:r>
-            <a:br/>
-            <a:r>
-              <a:t>• Validate local data and thresholds.</a:t>
-            </a:r>
-            <a:br/>
-            <a:r>
-              <a:t>• Authorized officers retain all decision authority.</a:t>
-            </a:r>
-          </a:p>
-        </p:txBody>
-      </p:sp>
-      <p:sp>
-        <p:nvSpPr>
-          <p:cNvPr id="6" name="Rounded Rectangle 5"/>
-          <p:cNvSpPr/>
-          <p:nvPr/>
-        </p:nvSpPr>
-        <p:spPr>
-          <a:xfrm>
-            <a:off x="8046720" y="1645920"/>
-            <a:ext cx="3383280" cy="4389120"/>
-          </a:xfrm>
-          <a:prstGeom prst="roundRect">
-            <a:avLst/>
-          </a:prstGeom>
-          <a:solidFill>
-            <a:srgbClr val="1A2438"/>
-          </a:solidFill>
-          <a:ln w="12700">
-            <a:solidFill>
-              <a:srgbClr val="334155"/>
-            </a:solidFill>
-          </a:ln>
-        </p:spPr>
-        <p:style>
-          <a:lnRef idx="1">
-            <a:schemeClr val="accent1"/>
-          </a:lnRef>
-          <a:fillRef idx="3">
-            <a:schemeClr val="accent1"/>
-          </a:fillRef>
-          <a:effectRef idx="2">
-            <a:schemeClr val="accent1"/>
-          </a:effectRef>
-          <a:fontRef idx="minor">
-            <a:schemeClr val="lt1"/>
-          </a:fontRef>
-        </p:style>
-        <p:txBody>
-          <a:bodyPr rtlCol="0" anchor="ctr" wrap="square"/>
-          <a:lstStyle/>
-          <a:p>
-            <a:pPr algn="ctr">
-              <a:defRPr b="1" sz="1400">
-                <a:solidFill>
-                  <a:srgbClr val="10B981"/>
-                </a:solidFill>
-              </a:defRPr>
-            </a:pPr>
-            <a:r>
-              <a:t>📻 Coastal Delta Communities</a:t>
-            </a:r>
-          </a:p>
-          <a:p>
-            <a:pPr>
-              <a:defRPr sz="1100" b="1">
-                <a:solidFill>
-                  <a:srgbClr val="F8FAFC"/>
-                </a:solidFill>
-              </a:defRPr>
-            </a:pPr>
-            <a:r>
-              <a:t>Agency-Approved Warnings</a:t>
-            </a:r>
-            <a:br/>
-          </a:p>
-          <a:p>
-            <a:pPr>
-              <a:defRPr sz="1100">
-                <a:solidFill>
-                  <a:srgbClr val="94A3B8"/>
-                </a:solidFill>
-              </a:defRPr>
-            </a:pPr>
-            <a:r>
-              <a:t>• Draft messages and voice workflows can be reviewed for local use.</a:t>
-            </a:r>
-            <a:br/>
-            <a:r>
-              <a:t>• Public alerts require agency approval and connected delivery channels.</a:t>
-            </a:r>
-            <a:br/>
-            <a:r>
-              <a:t>• The prototype does not send alerts.</a:t>
-            </a:r>
-          </a:p>
-        </p:txBody>
-      </p:sp>
-    </p:spTree>
-  </p:cSld>
-  <p:clrMapOvr>
-    <a:masterClrMapping/>
-  </p:clrMapOvr>
-</p:sld>
-</file>
-
 <file path=ppt/slides/slide9.xml><?xml version="1.0" encoding="utf-8"?>
 <p:sld xmlns:a="http://schemas.openxmlformats.org/drawingml/2006/main" xmlns:p="http://schemas.openxmlformats.org/presentationml/2006/main" xmlns:r="http://schemas.openxmlformats.org/officeDocument/2006/relationships">
   <p:cSld>
@@ -8236,7 +8345,7 @@
               </a:defRPr>
             </a:pPr>
             <a:r>
-              <a:t>BUILT FOR INDIA: OPERATIONAL SCOPE VS ROADMAP</a:t>
+              <a:t>GOOGLE CLOUD TEXT-TO-SPEECH: VOICE-FIRST IN 7 LANGUAGES</a:t>
             </a:r>
           </a:p>
         </p:txBody>
@@ -8264,7 +8373,7 @@
           <a:lstStyle/>
           <a:p>
             <a:pPr>
-              <a:defRPr sz="2200" b="1">
+              <a:defRPr sz="2100" b="1">
                 <a:solidFill>
                   <a:srgbClr val="F8FAFC"/>
                 </a:solidFill>
@@ -8272,7 +8381,7 @@
               </a:defRPr>
             </a:pPr>
             <a:r>
-              <a:t>Five configured state profiles are a starting point for validation—not national operational coverage.</a:t>
+              <a:t>Bridging the last-mile digital and literacy divide with high-fidelity Neural2 speech synthesis.</a:t>
             </a:r>
           </a:p>
         </p:txBody>
@@ -8286,7 +8395,123 @@
         <p:spPr>
           <a:xfrm>
             <a:off x="731520" y="1645920"/>
-            <a:ext cx="5120640" cy="4389120"/>
+            <a:ext cx="3383280" cy="4389120"/>
+          </a:xfrm>
+          <a:prstGeom prst="roundRect">
+            <a:avLst/>
+          </a:prstGeom>
+          <a:solidFill>
+            <a:srgbClr val="1A2438"/>
+          </a:solidFill>
+          <a:ln w="12700">
+            <a:solidFill>
+              <a:srgbClr val="38BDF8"/>
+            </a:solidFill>
+          </a:ln>
+        </p:spPr>
+        <p:style>
+          <a:lnRef idx="1">
+            <a:schemeClr val="accent1"/>
+          </a:lnRef>
+          <a:fillRef idx="3">
+            <a:schemeClr val="accent1"/>
+          </a:fillRef>
+          <a:effectRef idx="2">
+            <a:schemeClr val="accent1"/>
+          </a:effectRef>
+          <a:fontRef idx="minor">
+            <a:schemeClr val="lt1"/>
+          </a:fontRef>
+        </p:style>
+        <p:txBody>
+          <a:bodyPr rtlCol="0" anchor="ctr" wrap="square"/>
+          <a:lstStyle/>
+          <a:p>
+            <a:pPr algn="ctr">
+              <a:defRPr b="1" sz="1350">
+                <a:solidFill>
+                  <a:srgbClr val="38BDF8"/>
+                </a:solidFill>
+              </a:defRPr>
+            </a:pPr>
+            <a:r>
+              <a:t>🗣️ 7 Regional Indian Languages</a:t>
+            </a:r>
+          </a:p>
+          <a:p>
+            <a:br/>
+            <a:pPr>
+              <a:defRPr sz="1150" b="1">
+                <a:solidFill>
+                  <a:srgbClr val="F8FAFC"/>
+                </a:solidFill>
+              </a:defRPr>
+            </a:pPr>
+            <a:r>
+              <a:t>• Native Speech Synthesis:</a:t>
+            </a:r>
+          </a:p>
+          <a:p>
+            <a:pPr>
+              <a:defRPr sz="1050">
+                <a:solidFill>
+                  <a:srgbClr val="F8FAFC"/>
+                </a:solidFill>
+              </a:defRPr>
+            </a:pPr>
+            <a:r>
+              <a:t>• Bengali (bn-IN, Bashkar/Neural2-A)</a:t>
+            </a:r>
+            <a:br/>
+            <a:r>
+              <a:t>• Hindi (hi-IN, Swara/Neural2-D)</a:t>
+            </a:r>
+            <a:br/>
+            <a:r>
+              <a:t>• Odia (or-IN, Cloud TTS)</a:t>
+            </a:r>
+            <a:br/>
+            <a:r>
+              <a:t>• Telugu (te-IN, Mohan/Neural2-A)</a:t>
+            </a:r>
+            <a:br/>
+            <a:r>
+              <a:t>• Tamil (ta-IN, Pallavi/Neural2-A)</a:t>
+            </a:r>
+            <a:br/>
+            <a:r>
+              <a:t>• Gujarati (gu-IN, Dhwani/Neural2-A)</a:t>
+            </a:r>
+            <a:br/>
+            <a:r>
+              <a:t>• English (en-IN, Neural2-D)</a:t>
+            </a:r>
+          </a:p>
+          <a:p>
+            <a:br/>
+            <a:pPr>
+              <a:defRPr sz="1000">
+                <a:solidFill>
+                  <a:srgbClr val="94A3B8"/>
+                </a:solidFill>
+              </a:defRPr>
+            </a:pPr>
+            <a:r>
+              <a:t>• Top-level language switcher dynamically translates UI alerts and synthesized audio.</a:t>
+            </a:r>
+          </a:p>
+        </p:txBody>
+      </p:sp>
+      <p:sp>
+        <p:nvSpPr>
+          <p:cNvPr id="5" name="Rounded Rectangle 4"/>
+          <p:cNvSpPr/>
+          <p:nvPr/>
+        </p:nvSpPr>
+        <p:spPr>
+          <a:xfrm>
+            <a:off x="4389120" y="1645920"/>
+            <a:ext cx="3383280" cy="4389120"/>
           </a:xfrm>
           <a:prstGeom prst="roundRect">
             <a:avLst/>
@@ -8319,80 +8544,103 @@
           <a:lstStyle/>
           <a:p>
             <a:pPr algn="ctr">
-              <a:defRPr b="1" sz="1400">
+              <a:defRPr b="1" sz="1350">
                 <a:solidFill>
                   <a:srgbClr val="10B981"/>
                 </a:solidFill>
               </a:defRPr>
             </a:pPr>
             <a:r>
-              <a:t>✅ CONFIGURED DEMONSTRATION</a:t>
+              <a:t>⚡ 3-Tier Synthesis Resilience</a:t>
             </a:r>
           </a:p>
           <a:p>
             <a:br/>
             <a:pPr>
-              <a:defRPr sz="1150">
+              <a:defRPr sz="1150" b="1">
                 <a:solidFill>
                   <a:srgbClr val="F8FAFC"/>
                 </a:solidFill>
               </a:defRPr>
             </a:pPr>
             <a:r>
-              <a:t>• Historical storm examples are selected from a bundled catalog; confirm any live query separately.</a:t>
+              <a:t>• Tier 1: Google Cloud TTS</a:t>
+            </a:r>
+          </a:p>
+          <a:p>
+            <a:pPr>
+              <a:defRPr sz="1050">
+                <a:solidFill>
+                  <a:srgbClr val="94A3B8"/>
+                </a:solidFill>
+              </a:defRPr>
+            </a:pPr>
+            <a:r>
+              <a:t>High-definition Neural2 natural speech with customized rate and pitch for megaphone audio.</a:t>
             </a:r>
           </a:p>
           <a:p>
             <a:br/>
             <a:pPr>
-              <a:defRPr sz="1150">
+              <a:defRPr sz="1150" b="1">
                 <a:solidFill>
                   <a:srgbClr val="F8FAFC"/>
                 </a:solidFill>
               </a:defRPr>
             </a:pPr>
             <a:r>
-              <a:t>• Five state profiles use configured districts and scenario data; they are not agency integrations.</a:t>
+              <a:t>• Tier 2: gTTS Free Fallback</a:t>
+            </a:r>
+          </a:p>
+          <a:p>
+            <a:pPr>
+              <a:defRPr sz="1050">
+                <a:solidFill>
+                  <a:srgbClr val="94A3B8"/>
+                </a:solidFill>
+              </a:defRPr>
+            </a:pPr>
+            <a:r>
+              <a:t>Graceful zero-cost fallback when API quotas or internet connectivity are constrained.</a:t>
             </a:r>
           </a:p>
           <a:p>
             <a:br/>
             <a:pPr>
-              <a:defRPr sz="1150">
+              <a:defRPr sz="1150" b="1">
                 <a:solidFill>
                   <a:srgbClr val="F8FAFC"/>
                 </a:solidFill>
               </a:defRPr>
             </a:pPr>
             <a:r>
-              <a:t>• Seven language choices; messages and audio paths require review and per-run verification.</a:t>
-            </a:r>
-          </a:p>
-          <a:p>
-            <a:br/>
-            <a:pPr>
-              <a:defRPr sz="1100">
+              <a:t>• Tier 3: Pre-Rendered Audio</a:t>
+            </a:r>
+          </a:p>
+          <a:p>
+            <a:pPr>
+              <a:defRPr sz="1050">
                 <a:solidFill>
                   <a:srgbClr val="94A3B8"/>
                 </a:solidFill>
               </a:defRPr>
             </a:pPr>
             <a:r>
-              <a:t>• Compatible user-supplied track files can be explored; no live IMD feed is implied.</a:t>
-            </a:r>
-          </a:p>
-        </p:txBody>
-      </p:sp>
-      <p:sp>
-        <p:nvSpPr>
-          <p:cNvPr id="5" name="Rounded Rectangle 4"/>
+              <a:t>30 pre-rendered studio warning bulletins with emergency siren chimes ready for offline playback.</a:t>
+            </a:r>
+          </a:p>
+        </p:txBody>
+      </p:sp>
+      <p:sp>
+        <p:nvSpPr>
+          <p:cNvPr id="6" name="Rounded Rectangle 5"/>
           <p:cNvSpPr/>
           <p:nvPr/>
         </p:nvSpPr>
         <p:spPr>
           <a:xfrm>
-            <a:off x="6309360" y="1645920"/>
-            <a:ext cx="5120640" cy="4389120"/>
+            <a:off x="8046720" y="1645920"/>
+            <a:ext cx="3383280" cy="4389120"/>
           </a:xfrm>
           <a:prstGeom prst="roundRect">
             <a:avLst/>
@@ -8402,7 +8650,7 @@
           </a:solidFill>
           <a:ln w="12700">
             <a:solidFill>
-              <a:srgbClr val="38BDF8"/>
+              <a:srgbClr val="F97316"/>
             </a:solidFill>
           </a:ln>
         </p:spPr>
@@ -8425,66 +8673,77 @@
           <a:lstStyle/>
           <a:p>
             <a:pPr algn="ctr">
-              <a:defRPr b="1" sz="1400">
-                <a:solidFill>
-                  <a:srgbClr val="38BDF8"/>
-                </a:solidFill>
-              </a:defRPr>
-            </a:pPr>
-            <a:r>
-              <a:t>🚀 PLANNED PAN-INDIA EXPANSION</a:t>
+              <a:defRPr b="1" sz="1350">
+                <a:solidFill>
+                  <a:srgbClr val="F97316"/>
+                </a:solidFill>
+              </a:defRPr>
+            </a:pPr>
+            <a:r>
+              <a:t>📻 Reaching the Last Mile</a:t>
             </a:r>
           </a:p>
           <a:p>
             <a:br/>
             <a:pPr>
-              <a:defRPr sz="1150">
+              <a:defRPr sz="1150" b="1">
                 <a:solidFill>
                   <a:srgbClr val="F8FAFC"/>
                 </a:solidFill>
               </a:defRPr>
             </a:pPr>
             <a:r>
-              <a:t>• State partners must validate local boundaries, assets, populations, and thresholds.</a:t>
+              <a:t>• Accessible Disaster Alerting:</a:t>
+            </a:r>
+          </a:p>
+          <a:p>
+            <a:pPr>
+              <a:defRPr sz="1050">
+                <a:solidFill>
+                  <a:srgbClr val="94A3B8"/>
+                </a:solidFill>
+              </a:defRPr>
+            </a:pPr>
+            <a:r>
+              <a:t>SMS text alerts fail illiterate citizens, elderly populations, and families who lose electricity.</a:t>
             </a:r>
           </a:p>
           <a:p>
             <a:br/>
             <a:pPr>
-              <a:defRPr sz="1150">
+              <a:defRPr sz="1150" b="1">
                 <a:solidFill>
                   <a:srgbClr val="F8FAFC"/>
                 </a:solidFill>
               </a:defRPr>
             </a:pPr>
             <a:r>
-              <a:t>• Multilingual Extension: Spoken audio in Odia, Telugu, Tamil, Malayalam, and Marathi.</a:t>
+              <a:t>• Direct Community Audio:</a:t>
+            </a:r>
+          </a:p>
+          <a:p>
+            <a:pPr>
+              <a:defRPr sz="1050">
+                <a:solidFill>
+                  <a:srgbClr val="F8FAFC"/>
+                </a:solidFill>
+              </a:defRPr>
+            </a:pPr>
+            <a:r>
+              <a:t>Generates downloadable, broadcast-ready MP3s for local community radio, police loudspeaker vans, and boat siren systems.</a:t>
             </a:r>
           </a:p>
           <a:p>
             <a:br/>
             <a:pPr>
-              <a:defRPr sz="1150">
-                <a:solidFill>
-                  <a:srgbClr val="F8FAFC"/>
-                </a:solidFill>
-              </a:defRPr>
-            </a:pPr>
-            <a:r>
-              <a:t>• Live forecast and official bulletin sources require separate connection and validation.</a:t>
-            </a:r>
-          </a:p>
-          <a:p>
-            <a:br/>
-            <a:pPr>
-              <a:defRPr sz="1100">
+              <a:defRPr sz="1000">
                 <a:solidFill>
                   <a:srgbClr val="94A3B8"/>
                 </a:solidFill>
               </a:defRPr>
             </a:pPr>
             <a:r>
-              <a:t>• Core Scalability: Standard GeoPandas geospatial projection (EPSG:3857/4326) covers all 7,516 km of Indian coastline.</a:t>
+              <a:t>• 1-Click Playback: Play voice alerts directly in the browser with zero external player required.</a:t>
             </a:r>
           </a:p>
         </p:txBody>

</xml_diff>